<commit_message>
docs: document the Azure deployment (presentation slide + runbook changeset)
Adds a "Despliegue en Azure" slide to the TFM presentation deck, and
Changeset C09 as the detailed operational runbook for this and future
redeployments — architecture, env vars, step-by-step commands, and the two
real production bugs found and fixed during this deployment (cross-host CSRF
cookie, and the login lockout it caused once naively patched).

Co-Authored-By: Claude Sonnet 5 <noreply@anthropic.com>
</commit_message>
<xml_diff>
--- a/presentacion/TFM_BigSchool_Presentacion.pptx
+++ b/presentacion/TFM_BigSchool_Presentacion.pptx
@@ -36,6 +36,7 @@
     <p:sldId id="281" r:id="rId27"/>
     <p:sldId id="282" r:id="rId28"/>
     <p:sldId id="283" r:id="rId29"/>
+    <p:sldId id="287" r:id="rId38"/>
     <p:sldId id="284" r:id="rId30"/>
     <p:sldId id="285" r:id="rId31"/>
     <p:sldId id="286" r:id="rId32"/>
@@ -21302,7 +21303,7 @@
 </file>
 
 <file path=ppt/slides/slide29.xml><?xml version="1.0" encoding="utf-8"?>
-<p:sld xmlns:a="http://schemas.openxmlformats.org/drawingml/2006/main" xmlns:r="http://schemas.openxmlformats.org/officeDocument/2006/relationships" xmlns:p="http://schemas.openxmlformats.org/presentationml/2006/main">
+<p:sld xmlns:a="http://schemas.openxmlformats.org/drawingml/2006/main" xmlns:p="http://schemas.openxmlformats.org/presentationml/2006/main" xmlns:r="http://schemas.openxmlformats.org/officeDocument/2006/relationships">
   <p:cSld>
     <p:spTree>
       <p:nvGrpSpPr>
@@ -21310,14 +21311,7 @@
         <p:cNvGrpSpPr/>
         <p:nvPr/>
       </p:nvGrpSpPr>
-      <p:grpSpPr>
-        <a:xfrm>
-          <a:off x="0" y="0"/>
-          <a:ext cx="0" cy="0"/>
-          <a:chOff x="0" y="0"/>
-          <a:chExt cx="0" cy="0"/>
-        </a:xfrm>
-      </p:grpSpPr>
+      <p:grpSpPr/>
       <p:sp>
         <p:nvSpPr>
           <p:cNvPr id="2" name="Rectangle 1"/>
@@ -21436,7 +21430,7 @@
                 </a:solidFill>
                 <a:latin typeface="Space Grotesk"/>
               </a:rPr>
-              <a:t>Próximos pasos</a:t>
+              <a:t>Despliegue en Azure</a:t>
             </a:r>
           </a:p>
         </p:txBody>
@@ -21488,170 +21482,2230 @@
       </p:sp>
       <p:sp>
         <p:nvSpPr>
-          <p:cNvPr id="6" name="TextBox 5"/>
-          <p:cNvSpPr txBox="1"/>
-          <p:nvPr/>
-        </p:nvSpPr>
-        <p:spPr>
-          <a:xfrm>
-            <a:off x="777240" y="2103120"/>
-            <a:ext cx="10241280" cy="3108960"/>
-          </a:xfrm>
-          <a:prstGeom prst="rect">
-            <a:avLst/>
-          </a:prstGeom>
-          <a:noFill/>
-        </p:spPr>
-        <p:txBody>
-          <a:bodyPr wrap="square" lIns="0" tIns="0" rIns="0" bIns="0">
-            <a:spAutoFit/>
-          </a:bodyPr>
-          <a:lstStyle/>
-          <a:p>
-            <a:pPr>
-              <a:lnSpc>
-                <a:spcPct val="160000"/>
-              </a:lnSpc>
-              <a:spcAft>
-                <a:spcPts val="400"/>
-              </a:spcAft>
-            </a:pPr>
-            <a:r>
-              <a:rPr sz="1650" b="1">
+          <p:cNvPr id="6" name="Rounded Rectangle 5"/>
+          <p:cNvSpPr/>
+          <p:nvPr/>
+        </p:nvSpPr>
+        <p:spPr>
+          <a:xfrm>
+            <a:off x="685800" y="1874519"/>
+            <a:ext cx="3429000" cy="713232"/>
+          </a:xfrm>
+          <a:prstGeom prst="roundRect">
+            <a:avLst>
+              <a:gd name="adj" fmla="val 6000"/>
+            </a:avLst>
+          </a:prstGeom>
+          <a:solidFill>
+            <a:srgbClr val="101318"/>
+          </a:solidFill>
+          <a:ln w="12700">
+            <a:solidFill>
+              <a:srgbClr val="1D222B"/>
+            </a:solidFill>
+          </a:ln>
+          <a:effectLst/>
+        </p:spPr>
+        <p:style>
+          <a:lnRef idx="1">
+            <a:schemeClr val="accent1"/>
+          </a:lnRef>
+          <a:fillRef idx="3">
+            <a:schemeClr val="accent1"/>
+          </a:fillRef>
+          <a:effectRef idx="2">
+            <a:schemeClr val="accent1"/>
+          </a:effectRef>
+          <a:fontRef idx="minor">
+            <a:schemeClr val="lt1"/>
+          </a:fontRef>
+        </p:style>
+        <p:txBody>
+          <a:bodyPr rtlCol="0" anchor="ctr"/>
+          <a:lstStyle/>
+          <a:p>
+            <a:pPr algn="ctr"/>
+            <a:endParaRPr/>
+          </a:p>
+        </p:txBody>
+      </p:sp>
+      <p:sp>
+        <p:nvSpPr>
+          <p:cNvPr id="7" name="TextBox 6"/>
+          <p:cNvSpPr txBox="1"/>
+          <p:nvPr/>
+        </p:nvSpPr>
+        <p:spPr>
+          <a:xfrm>
+            <a:off x="868680" y="1984247"/>
+            <a:ext cx="822960" cy="457200"/>
+          </a:xfrm>
+          <a:prstGeom prst="rect">
+            <a:avLst/>
+          </a:prstGeom>
+          <a:noFill/>
+        </p:spPr>
+        <p:txBody>
+          <a:bodyPr wrap="square" lIns="0" tIns="0" rIns="0" bIns="0" anchor="t">
+            <a:spAutoFit/>
+          </a:bodyPr>
+          <a:lstStyle/>
+          <a:p>
+            <a:pPr algn="l">
+              <a:lnSpc>
+                <a:spcPct val="115000"/>
+              </a:lnSpc>
+            </a:pPr>
+            <a:r>
+              <a:rPr sz="1500" b="1" i="0">
                 <a:solidFill>
                   <a:srgbClr val="C9A45C"/>
                 </a:solidFill>
-                <a:latin typeface="Space Grotesk"/>
-              </a:rPr>
-              <a:t>▪  </a:t>
-            </a:r>
-            <a:r>
-              <a:rPr sz="1650">
-                <a:solidFill>
-                  <a:srgbClr val="99A0AB"/>
-                </a:solidFill>
-                <a:latin typeface="Space Grotesk"/>
-              </a:rPr>
-              <a:t>Vista consolidada multi-cartera y multi-moneda</a:t>
-            </a:r>
-          </a:p>
-          <a:p>
-            <a:pPr>
-              <a:lnSpc>
-                <a:spcPct val="160000"/>
-              </a:lnSpc>
-              <a:spcAft>
-                <a:spcPts val="400"/>
-              </a:spcAft>
-            </a:pPr>
-            <a:r>
-              <a:rPr sz="1650" b="1">
+                <a:latin typeface="JetBrains Mono"/>
+              </a:rPr>
+              <a:t>RG</a:t>
+            </a:r>
+          </a:p>
+        </p:txBody>
+      </p:sp>
+      <p:sp>
+        <p:nvSpPr>
+          <p:cNvPr id="8" name="TextBox 7"/>
+          <p:cNvSpPr txBox="1"/>
+          <p:nvPr/>
+        </p:nvSpPr>
+        <p:spPr>
+          <a:xfrm>
+            <a:off x="1645920" y="1947671"/>
+            <a:ext cx="1965960" cy="548640"/>
+          </a:xfrm>
+          <a:prstGeom prst="rect">
+            <a:avLst/>
+          </a:prstGeom>
+          <a:noFill/>
+        </p:spPr>
+        <p:txBody>
+          <a:bodyPr wrap="square" lIns="0" tIns="0" rIns="0" bIns="0" anchor="t">
+            <a:spAutoFit/>
+          </a:bodyPr>
+          <a:lstStyle/>
+          <a:p>
+            <a:pPr algn="l">
+              <a:lnSpc>
+                <a:spcPct val="105000"/>
+              </a:lnSpc>
+            </a:pPr>
+            <a:r>
+              <a:rPr sz="1150" b="0" i="0">
+                <a:solidFill>
+                  <a:srgbClr val="E7E9ED"/>
+                </a:solidFill>
+                <a:latin typeface="Space Grotesk"/>
+              </a:rPr>
+              <a:t>Resource Group en Azure (cuenta Eural)</a:t>
+            </a:r>
+          </a:p>
+        </p:txBody>
+      </p:sp>
+      <p:sp>
+        <p:nvSpPr>
+          <p:cNvPr id="9" name="Oval 8"/>
+          <p:cNvSpPr/>
+          <p:nvPr/>
+        </p:nvSpPr>
+        <p:spPr>
+          <a:xfrm>
+            <a:off x="3657600" y="2084831"/>
+            <a:ext cx="292608" cy="292608"/>
+          </a:xfrm>
+          <a:prstGeom prst="ellipse">
+            <a:avLst/>
+          </a:prstGeom>
+          <a:solidFill>
+            <a:srgbClr val="10261B"/>
+          </a:solidFill>
+          <a:ln w="12700">
+            <a:solidFill>
+              <a:srgbClr val="4FBF87"/>
+            </a:solidFill>
+          </a:ln>
+          <a:effectLst/>
+        </p:spPr>
+        <p:style>
+          <a:lnRef idx="1">
+            <a:schemeClr val="accent1"/>
+          </a:lnRef>
+          <a:fillRef idx="3">
+            <a:schemeClr val="accent1"/>
+          </a:fillRef>
+          <a:effectRef idx="2">
+            <a:schemeClr val="accent1"/>
+          </a:effectRef>
+          <a:fontRef idx="minor">
+            <a:schemeClr val="lt1"/>
+          </a:fontRef>
+        </p:style>
+        <p:txBody>
+          <a:bodyPr lIns="0" tIns="0" rIns="0" bIns="0" rtlCol="0" anchor="ctr"/>
+          <a:lstStyle/>
+          <a:p>
+            <a:pPr algn="ctr"/>
+            <a:r>
+              <a:rPr sz="1300" b="1">
+                <a:solidFill>
+                  <a:srgbClr val="4FBF87"/>
+                </a:solidFill>
+                <a:latin typeface="Space Grotesk"/>
+              </a:rPr>
+              <a:t>✓</a:t>
+            </a:r>
+          </a:p>
+        </p:txBody>
+      </p:sp>
+      <p:sp>
+        <p:nvSpPr>
+          <p:cNvPr id="10" name="Rounded Rectangle 9"/>
+          <p:cNvSpPr/>
+          <p:nvPr/>
+        </p:nvSpPr>
+        <p:spPr>
+          <a:xfrm>
+            <a:off x="4279392" y="1874519"/>
+            <a:ext cx="3429000" cy="713232"/>
+          </a:xfrm>
+          <a:prstGeom prst="roundRect">
+            <a:avLst>
+              <a:gd name="adj" fmla="val 6000"/>
+            </a:avLst>
+          </a:prstGeom>
+          <a:solidFill>
+            <a:srgbClr val="101318"/>
+          </a:solidFill>
+          <a:ln w="12700">
+            <a:solidFill>
+              <a:srgbClr val="1D222B"/>
+            </a:solidFill>
+          </a:ln>
+          <a:effectLst/>
+        </p:spPr>
+        <p:style>
+          <a:lnRef idx="1">
+            <a:schemeClr val="accent1"/>
+          </a:lnRef>
+          <a:fillRef idx="3">
+            <a:schemeClr val="accent1"/>
+          </a:fillRef>
+          <a:effectRef idx="2">
+            <a:schemeClr val="accent1"/>
+          </a:effectRef>
+          <a:fontRef idx="minor">
+            <a:schemeClr val="lt1"/>
+          </a:fontRef>
+        </p:style>
+        <p:txBody>
+          <a:bodyPr rtlCol="0" anchor="ctr"/>
+          <a:lstStyle/>
+          <a:p>
+            <a:pPr algn="ctr"/>
+            <a:endParaRPr/>
+          </a:p>
+        </p:txBody>
+      </p:sp>
+      <p:sp>
+        <p:nvSpPr>
+          <p:cNvPr id="11" name="TextBox 10"/>
+          <p:cNvSpPr txBox="1"/>
+          <p:nvPr/>
+        </p:nvSpPr>
+        <p:spPr>
+          <a:xfrm>
+            <a:off x="4462272" y="1984247"/>
+            <a:ext cx="822960" cy="457200"/>
+          </a:xfrm>
+          <a:prstGeom prst="rect">
+            <a:avLst/>
+          </a:prstGeom>
+          <a:noFill/>
+        </p:spPr>
+        <p:txBody>
+          <a:bodyPr wrap="square" lIns="0" tIns="0" rIns="0" bIns="0" anchor="t">
+            <a:spAutoFit/>
+          </a:bodyPr>
+          <a:lstStyle/>
+          <a:p>
+            <a:pPr algn="l">
+              <a:lnSpc>
+                <a:spcPct val="115000"/>
+              </a:lnSpc>
+            </a:pPr>
+            <a:r>
+              <a:rPr sz="1500" b="1" i="0">
                 <a:solidFill>
                   <a:srgbClr val="C9A45C"/>
                 </a:solidFill>
-                <a:latin typeface="Space Grotesk"/>
-              </a:rPr>
-              <a:t>▪  </a:t>
-            </a:r>
-            <a:r>
-              <a:rPr sz="1650">
-                <a:solidFill>
-                  <a:srgbClr val="99A0AB"/>
-                </a:solidFill>
-                <a:latin typeface="Space Grotesk"/>
-              </a:rPr>
-              <a:t>Notificaciones push (PWA)</a:t>
-            </a:r>
-          </a:p>
-          <a:p>
-            <a:pPr>
-              <a:lnSpc>
-                <a:spcPct val="160000"/>
-              </a:lnSpc>
-              <a:spcAft>
-                <a:spcPts val="400"/>
-              </a:spcAft>
-            </a:pPr>
-            <a:r>
-              <a:rPr sz="1650" b="1">
+                <a:latin typeface="JetBrains Mono"/>
+              </a:rPr>
+              <a:t>ENV</a:t>
+            </a:r>
+          </a:p>
+        </p:txBody>
+      </p:sp>
+      <p:sp>
+        <p:nvSpPr>
+          <p:cNvPr id="12" name="TextBox 11"/>
+          <p:cNvSpPr txBox="1"/>
+          <p:nvPr/>
+        </p:nvSpPr>
+        <p:spPr>
+          <a:xfrm>
+            <a:off x="5239512" y="1947671"/>
+            <a:ext cx="1965960" cy="548640"/>
+          </a:xfrm>
+          <a:prstGeom prst="rect">
+            <a:avLst/>
+          </a:prstGeom>
+          <a:noFill/>
+        </p:spPr>
+        <p:txBody>
+          <a:bodyPr wrap="square" lIns="0" tIns="0" rIns="0" bIns="0" anchor="t">
+            <a:spAutoFit/>
+          </a:bodyPr>
+          <a:lstStyle/>
+          <a:p>
+            <a:pPr algn="l">
+              <a:lnSpc>
+                <a:spcPct val="105000"/>
+              </a:lnSpc>
+            </a:pPr>
+            <a:r>
+              <a:rPr sz="1150" b="0" i="0">
+                <a:solidFill>
+                  <a:srgbClr val="E7E9ED"/>
+                </a:solidFill>
+                <a:latin typeface="Space Grotesk"/>
+              </a:rPr>
+              <a:t>Container Apps Environment (North Europe)</a:t>
+            </a:r>
+          </a:p>
+        </p:txBody>
+      </p:sp>
+      <p:sp>
+        <p:nvSpPr>
+          <p:cNvPr id="13" name="Oval 12"/>
+          <p:cNvSpPr/>
+          <p:nvPr/>
+        </p:nvSpPr>
+        <p:spPr>
+          <a:xfrm>
+            <a:off x="7251192" y="2084831"/>
+            <a:ext cx="292608" cy="292608"/>
+          </a:xfrm>
+          <a:prstGeom prst="ellipse">
+            <a:avLst/>
+          </a:prstGeom>
+          <a:solidFill>
+            <a:srgbClr val="10261B"/>
+          </a:solidFill>
+          <a:ln w="12700">
+            <a:solidFill>
+              <a:srgbClr val="4FBF87"/>
+            </a:solidFill>
+          </a:ln>
+          <a:effectLst/>
+        </p:spPr>
+        <p:style>
+          <a:lnRef idx="1">
+            <a:schemeClr val="accent1"/>
+          </a:lnRef>
+          <a:fillRef idx="3">
+            <a:schemeClr val="accent1"/>
+          </a:fillRef>
+          <a:effectRef idx="2">
+            <a:schemeClr val="accent1"/>
+          </a:effectRef>
+          <a:fontRef idx="minor">
+            <a:schemeClr val="lt1"/>
+          </a:fontRef>
+        </p:style>
+        <p:txBody>
+          <a:bodyPr lIns="0" tIns="0" rIns="0" bIns="0" rtlCol="0" anchor="ctr"/>
+          <a:lstStyle/>
+          <a:p>
+            <a:pPr algn="ctr"/>
+            <a:r>
+              <a:rPr sz="1300" b="1">
+                <a:solidFill>
+                  <a:srgbClr val="4FBF87"/>
+                </a:solidFill>
+                <a:latin typeface="Space Grotesk"/>
+              </a:rPr>
+              <a:t>✓</a:t>
+            </a:r>
+          </a:p>
+        </p:txBody>
+      </p:sp>
+      <p:sp>
+        <p:nvSpPr>
+          <p:cNvPr id="14" name="Rounded Rectangle 13"/>
+          <p:cNvSpPr/>
+          <p:nvPr/>
+        </p:nvSpPr>
+        <p:spPr>
+          <a:xfrm>
+            <a:off x="7872984" y="1874519"/>
+            <a:ext cx="3429000" cy="713232"/>
+          </a:xfrm>
+          <a:prstGeom prst="roundRect">
+            <a:avLst>
+              <a:gd name="adj" fmla="val 6000"/>
+            </a:avLst>
+          </a:prstGeom>
+          <a:solidFill>
+            <a:srgbClr val="101318"/>
+          </a:solidFill>
+          <a:ln w="12700">
+            <a:solidFill>
+              <a:srgbClr val="1D222B"/>
+            </a:solidFill>
+          </a:ln>
+          <a:effectLst/>
+        </p:spPr>
+        <p:style>
+          <a:lnRef idx="1">
+            <a:schemeClr val="accent1"/>
+          </a:lnRef>
+          <a:fillRef idx="3">
+            <a:schemeClr val="accent1"/>
+          </a:fillRef>
+          <a:effectRef idx="2">
+            <a:schemeClr val="accent1"/>
+          </a:effectRef>
+          <a:fontRef idx="minor">
+            <a:schemeClr val="lt1"/>
+          </a:fontRef>
+        </p:style>
+        <p:txBody>
+          <a:bodyPr rtlCol="0" anchor="ctr"/>
+          <a:lstStyle/>
+          <a:p>
+            <a:pPr algn="ctr"/>
+            <a:endParaRPr/>
+          </a:p>
+        </p:txBody>
+      </p:sp>
+      <p:sp>
+        <p:nvSpPr>
+          <p:cNvPr id="15" name="TextBox 14"/>
+          <p:cNvSpPr txBox="1"/>
+          <p:nvPr/>
+        </p:nvSpPr>
+        <p:spPr>
+          <a:xfrm>
+            <a:off x="8055864" y="1984247"/>
+            <a:ext cx="822960" cy="457200"/>
+          </a:xfrm>
+          <a:prstGeom prst="rect">
+            <a:avLst/>
+          </a:prstGeom>
+          <a:noFill/>
+        </p:spPr>
+        <p:txBody>
+          <a:bodyPr wrap="square" lIns="0" tIns="0" rIns="0" bIns="0" anchor="t">
+            <a:spAutoFit/>
+          </a:bodyPr>
+          <a:lstStyle/>
+          <a:p>
+            <a:pPr algn="l">
+              <a:lnSpc>
+                <a:spcPct val="115000"/>
+              </a:lnSpc>
+            </a:pPr>
+            <a:r>
+              <a:rPr sz="1500" b="1" i="0">
                 <a:solidFill>
                   <a:srgbClr val="C9A45C"/>
                 </a:solidFill>
-                <a:latin typeface="Space Grotesk"/>
-              </a:rPr>
-              <a:t>▪  </a:t>
-            </a:r>
-            <a:r>
-              <a:rPr sz="1650">
-                <a:solidFill>
-                  <a:srgbClr val="99A0AB"/>
-                </a:solidFill>
-                <a:latin typeface="Space Grotesk"/>
-              </a:rPr>
-              <a:t>Fuentes adicionales de análisis con IA (noticias, feeds automáticos)</a:t>
-            </a:r>
-          </a:p>
-          <a:p>
-            <a:pPr>
-              <a:lnSpc>
-                <a:spcPct val="160000"/>
-              </a:lnSpc>
-              <a:spcAft>
-                <a:spcPts val="400"/>
-              </a:spcAft>
-            </a:pPr>
-            <a:r>
-              <a:rPr sz="1650" b="1">
+                <a:latin typeface="JetBrains Mono"/>
+              </a:rPr>
+              <a:t>API</a:t>
+            </a:r>
+          </a:p>
+        </p:txBody>
+      </p:sp>
+      <p:sp>
+        <p:nvSpPr>
+          <p:cNvPr id="16" name="TextBox 15"/>
+          <p:cNvSpPr txBox="1"/>
+          <p:nvPr/>
+        </p:nvSpPr>
+        <p:spPr>
+          <a:xfrm>
+            <a:off x="8833104" y="1947671"/>
+            <a:ext cx="1965960" cy="548640"/>
+          </a:xfrm>
+          <a:prstGeom prst="rect">
+            <a:avLst/>
+          </a:prstGeom>
+          <a:noFill/>
+        </p:spPr>
+        <p:txBody>
+          <a:bodyPr wrap="square" lIns="0" tIns="0" rIns="0" bIns="0" anchor="t">
+            <a:spAutoFit/>
+          </a:bodyPr>
+          <a:lstStyle/>
+          <a:p>
+            <a:pPr algn="l">
+              <a:lnSpc>
+                <a:spcPct val="105000"/>
+              </a:lnSpc>
+            </a:pPr>
+            <a:r>
+              <a:rPr sz="1150" b="0" i="0">
+                <a:solidFill>
+                  <a:srgbClr val="E7E9ED"/>
+                </a:solidFill>
+                <a:latin typeface="Space Grotesk"/>
+              </a:rPr>
+              <a:t>Backend FastAPI + Uvicorn</a:t>
+            </a:r>
+          </a:p>
+        </p:txBody>
+      </p:sp>
+      <p:sp>
+        <p:nvSpPr>
+          <p:cNvPr id="17" name="Oval 16"/>
+          <p:cNvSpPr/>
+          <p:nvPr/>
+        </p:nvSpPr>
+        <p:spPr>
+          <a:xfrm>
+            <a:off x="10844784" y="2084831"/>
+            <a:ext cx="292608" cy="292608"/>
+          </a:xfrm>
+          <a:prstGeom prst="ellipse">
+            <a:avLst/>
+          </a:prstGeom>
+          <a:solidFill>
+            <a:srgbClr val="10261B"/>
+          </a:solidFill>
+          <a:ln w="12700">
+            <a:solidFill>
+              <a:srgbClr val="4FBF87"/>
+            </a:solidFill>
+          </a:ln>
+          <a:effectLst/>
+        </p:spPr>
+        <p:style>
+          <a:lnRef idx="1">
+            <a:schemeClr val="accent1"/>
+          </a:lnRef>
+          <a:fillRef idx="3">
+            <a:schemeClr val="accent1"/>
+          </a:fillRef>
+          <a:effectRef idx="2">
+            <a:schemeClr val="accent1"/>
+          </a:effectRef>
+          <a:fontRef idx="minor">
+            <a:schemeClr val="lt1"/>
+          </a:fontRef>
+        </p:style>
+        <p:txBody>
+          <a:bodyPr lIns="0" tIns="0" rIns="0" bIns="0" rtlCol="0" anchor="ctr"/>
+          <a:lstStyle/>
+          <a:p>
+            <a:pPr algn="ctr"/>
+            <a:r>
+              <a:rPr sz="1300" b="1">
+                <a:solidFill>
+                  <a:srgbClr val="4FBF87"/>
+                </a:solidFill>
+                <a:latin typeface="Space Grotesk"/>
+              </a:rPr>
+              <a:t>✓</a:t>
+            </a:r>
+          </a:p>
+        </p:txBody>
+      </p:sp>
+      <p:sp>
+        <p:nvSpPr>
+          <p:cNvPr id="18" name="Rounded Rectangle 17"/>
+          <p:cNvSpPr/>
+          <p:nvPr/>
+        </p:nvSpPr>
+        <p:spPr>
+          <a:xfrm>
+            <a:off x="685800" y="2734055"/>
+            <a:ext cx="3429000" cy="713232"/>
+          </a:xfrm>
+          <a:prstGeom prst="roundRect">
+            <a:avLst>
+              <a:gd name="adj" fmla="val 6000"/>
+            </a:avLst>
+          </a:prstGeom>
+          <a:solidFill>
+            <a:srgbClr val="101318"/>
+          </a:solidFill>
+          <a:ln w="12700">
+            <a:solidFill>
+              <a:srgbClr val="1D222B"/>
+            </a:solidFill>
+          </a:ln>
+          <a:effectLst/>
+        </p:spPr>
+        <p:style>
+          <a:lnRef idx="1">
+            <a:schemeClr val="accent1"/>
+          </a:lnRef>
+          <a:fillRef idx="3">
+            <a:schemeClr val="accent1"/>
+          </a:fillRef>
+          <a:effectRef idx="2">
+            <a:schemeClr val="accent1"/>
+          </a:effectRef>
+          <a:fontRef idx="minor">
+            <a:schemeClr val="lt1"/>
+          </a:fontRef>
+        </p:style>
+        <p:txBody>
+          <a:bodyPr rtlCol="0" anchor="ctr"/>
+          <a:lstStyle/>
+          <a:p>
+            <a:pPr algn="ctr"/>
+            <a:endParaRPr/>
+          </a:p>
+        </p:txBody>
+      </p:sp>
+      <p:sp>
+        <p:nvSpPr>
+          <p:cNvPr id="19" name="TextBox 18"/>
+          <p:cNvSpPr txBox="1"/>
+          <p:nvPr/>
+        </p:nvSpPr>
+        <p:spPr>
+          <a:xfrm>
+            <a:off x="868680" y="2843783"/>
+            <a:ext cx="822960" cy="457200"/>
+          </a:xfrm>
+          <a:prstGeom prst="rect">
+            <a:avLst/>
+          </a:prstGeom>
+          <a:noFill/>
+        </p:spPr>
+        <p:txBody>
+          <a:bodyPr wrap="square" lIns="0" tIns="0" rIns="0" bIns="0" anchor="t">
+            <a:spAutoFit/>
+          </a:bodyPr>
+          <a:lstStyle/>
+          <a:p>
+            <a:pPr algn="l">
+              <a:lnSpc>
+                <a:spcPct val="115000"/>
+              </a:lnSpc>
+            </a:pPr>
+            <a:r>
+              <a:rPr sz="1500" b="1" i="0">
                 <a:solidFill>
                   <a:srgbClr val="C9A45C"/>
                 </a:solidFill>
-                <a:latin typeface="Space Grotesk"/>
-              </a:rPr>
-              <a:t>▪  </a:t>
-            </a:r>
-            <a:r>
-              <a:rPr sz="1650">
-                <a:solidFill>
-                  <a:srgbClr val="99A0AB"/>
-                </a:solidFill>
-                <a:latin typeface="Space Grotesk"/>
-              </a:rPr>
-              <a:t>Roles y permisos adicionales según necesidades reales de uso</a:t>
-            </a:r>
-          </a:p>
-          <a:p>
-            <a:pPr>
-              <a:lnSpc>
-                <a:spcPct val="160000"/>
-              </a:lnSpc>
-              <a:spcAft>
-                <a:spcPts val="400"/>
-              </a:spcAft>
-            </a:pPr>
-            <a:r>
-              <a:rPr sz="1650" b="1">
+                <a:latin typeface="JetBrains Mono"/>
+              </a:rPr>
+              <a:t>CEL</a:t>
+            </a:r>
+          </a:p>
+        </p:txBody>
+      </p:sp>
+      <p:sp>
+        <p:nvSpPr>
+          <p:cNvPr id="20" name="TextBox 19"/>
+          <p:cNvSpPr txBox="1"/>
+          <p:nvPr/>
+        </p:nvSpPr>
+        <p:spPr>
+          <a:xfrm>
+            <a:off x="1645920" y="2807207"/>
+            <a:ext cx="1965960" cy="548640"/>
+          </a:xfrm>
+          <a:prstGeom prst="rect">
+            <a:avLst/>
+          </a:prstGeom>
+          <a:noFill/>
+        </p:spPr>
+        <p:txBody>
+          <a:bodyPr wrap="square" lIns="0" tIns="0" rIns="0" bIns="0" anchor="t">
+            <a:spAutoFit/>
+          </a:bodyPr>
+          <a:lstStyle/>
+          <a:p>
+            <a:pPr algn="l">
+              <a:lnSpc>
+                <a:spcPct val="105000"/>
+              </a:lnSpc>
+            </a:pPr>
+            <a:r>
+              <a:rPr sz="1150" b="0" i="0">
+                <a:solidFill>
+                  <a:srgbClr val="E7E9ED"/>
+                </a:solidFill>
+                <a:latin typeface="Space Grotesk"/>
+              </a:rPr>
+              <a:t>Worker Celery (script dedicado)</a:t>
+            </a:r>
+          </a:p>
+        </p:txBody>
+      </p:sp>
+      <p:sp>
+        <p:nvSpPr>
+          <p:cNvPr id="21" name="Oval 20"/>
+          <p:cNvSpPr/>
+          <p:nvPr/>
+        </p:nvSpPr>
+        <p:spPr>
+          <a:xfrm>
+            <a:off x="3657600" y="2944367"/>
+            <a:ext cx="292608" cy="292608"/>
+          </a:xfrm>
+          <a:prstGeom prst="ellipse">
+            <a:avLst/>
+          </a:prstGeom>
+          <a:solidFill>
+            <a:srgbClr val="10261B"/>
+          </a:solidFill>
+          <a:ln w="12700">
+            <a:solidFill>
+              <a:srgbClr val="4FBF87"/>
+            </a:solidFill>
+          </a:ln>
+          <a:effectLst/>
+        </p:spPr>
+        <p:style>
+          <a:lnRef idx="1">
+            <a:schemeClr val="accent1"/>
+          </a:lnRef>
+          <a:fillRef idx="3">
+            <a:schemeClr val="accent1"/>
+          </a:fillRef>
+          <a:effectRef idx="2">
+            <a:schemeClr val="accent1"/>
+          </a:effectRef>
+          <a:fontRef idx="minor">
+            <a:schemeClr val="lt1"/>
+          </a:fontRef>
+        </p:style>
+        <p:txBody>
+          <a:bodyPr lIns="0" tIns="0" rIns="0" bIns="0" rtlCol="0" anchor="ctr"/>
+          <a:lstStyle/>
+          <a:p>
+            <a:pPr algn="ctr"/>
+            <a:r>
+              <a:rPr sz="1300" b="1">
+                <a:solidFill>
+                  <a:srgbClr val="4FBF87"/>
+                </a:solidFill>
+                <a:latin typeface="Space Grotesk"/>
+              </a:rPr>
+              <a:t>✓</a:t>
+            </a:r>
+          </a:p>
+        </p:txBody>
+      </p:sp>
+      <p:sp>
+        <p:nvSpPr>
+          <p:cNvPr id="22" name="Rounded Rectangle 21"/>
+          <p:cNvSpPr/>
+          <p:nvPr/>
+        </p:nvSpPr>
+        <p:spPr>
+          <a:xfrm>
+            <a:off x="4279392" y="2734055"/>
+            <a:ext cx="3429000" cy="713232"/>
+          </a:xfrm>
+          <a:prstGeom prst="roundRect">
+            <a:avLst>
+              <a:gd name="adj" fmla="val 6000"/>
+            </a:avLst>
+          </a:prstGeom>
+          <a:solidFill>
+            <a:srgbClr val="101318"/>
+          </a:solidFill>
+          <a:ln w="12700">
+            <a:solidFill>
+              <a:srgbClr val="1D222B"/>
+            </a:solidFill>
+          </a:ln>
+          <a:effectLst/>
+        </p:spPr>
+        <p:style>
+          <a:lnRef idx="1">
+            <a:schemeClr val="accent1"/>
+          </a:lnRef>
+          <a:fillRef idx="3">
+            <a:schemeClr val="accent1"/>
+          </a:fillRef>
+          <a:effectRef idx="2">
+            <a:schemeClr val="accent1"/>
+          </a:effectRef>
+          <a:fontRef idx="minor">
+            <a:schemeClr val="lt1"/>
+          </a:fontRef>
+        </p:style>
+        <p:txBody>
+          <a:bodyPr rtlCol="0" anchor="ctr"/>
+          <a:lstStyle/>
+          <a:p>
+            <a:pPr algn="ctr"/>
+            <a:endParaRPr/>
+          </a:p>
+        </p:txBody>
+      </p:sp>
+      <p:sp>
+        <p:nvSpPr>
+          <p:cNvPr id="23" name="TextBox 22"/>
+          <p:cNvSpPr txBox="1"/>
+          <p:nvPr/>
+        </p:nvSpPr>
+        <p:spPr>
+          <a:xfrm>
+            <a:off x="4462272" y="2843783"/>
+            <a:ext cx="822960" cy="457200"/>
+          </a:xfrm>
+          <a:prstGeom prst="rect">
+            <a:avLst/>
+          </a:prstGeom>
+          <a:noFill/>
+        </p:spPr>
+        <p:txBody>
+          <a:bodyPr wrap="square" lIns="0" tIns="0" rIns="0" bIns="0" anchor="t">
+            <a:spAutoFit/>
+          </a:bodyPr>
+          <a:lstStyle/>
+          <a:p>
+            <a:pPr algn="l">
+              <a:lnSpc>
+                <a:spcPct val="115000"/>
+              </a:lnSpc>
+            </a:pPr>
+            <a:r>
+              <a:rPr sz="1500" b="1" i="0">
                 <a:solidFill>
                   <a:srgbClr val="C9A45C"/>
                 </a:solidFill>
-                <a:latin typeface="Space Grotesk"/>
-              </a:rPr>
-              <a:t>▪  </a:t>
-            </a:r>
-            <a:r>
-              <a:rPr sz="1650">
-                <a:solidFill>
-                  <a:srgbClr val="99A0AB"/>
-                </a:solidFill>
-                <a:latin typeface="Space Grotesk"/>
-              </a:rPr>
-              <a:t>Generación automática de tipos frontend/backend desde OpenAPI</a:t>
-            </a:r>
-          </a:p>
-        </p:txBody>
-      </p:sp>
-      <p:sp>
-        <p:nvSpPr>
-          <p:cNvPr id="7" name="TextBox 6"/>
+                <a:latin typeface="JetBrains Mono"/>
+              </a:rPr>
+              <a:t>WEB</a:t>
+            </a:r>
+          </a:p>
+        </p:txBody>
+      </p:sp>
+      <p:sp>
+        <p:nvSpPr>
+          <p:cNvPr id="24" name="TextBox 23"/>
+          <p:cNvSpPr txBox="1"/>
+          <p:nvPr/>
+        </p:nvSpPr>
+        <p:spPr>
+          <a:xfrm>
+            <a:off x="5239512" y="2807207"/>
+            <a:ext cx="1965960" cy="548640"/>
+          </a:xfrm>
+          <a:prstGeom prst="rect">
+            <a:avLst/>
+          </a:prstGeom>
+          <a:noFill/>
+        </p:spPr>
+        <p:txBody>
+          <a:bodyPr wrap="square" lIns="0" tIns="0" rIns="0" bIns="0" anchor="t">
+            <a:spAutoFit/>
+          </a:bodyPr>
+          <a:lstStyle/>
+          <a:p>
+            <a:pPr algn="l">
+              <a:lnSpc>
+                <a:spcPct val="105000"/>
+              </a:lnSpc>
+            </a:pPr>
+            <a:r>
+              <a:rPr sz="1150" b="0" i="0">
+                <a:solidFill>
+                  <a:srgbClr val="E7E9ED"/>
+                </a:solidFill>
+                <a:latin typeface="Space Grotesk"/>
+              </a:rPr>
+              <a:t>Frontend Nginx (build estático)</a:t>
+            </a:r>
+          </a:p>
+        </p:txBody>
+      </p:sp>
+      <p:sp>
+        <p:nvSpPr>
+          <p:cNvPr id="25" name="Oval 24"/>
+          <p:cNvSpPr/>
+          <p:nvPr/>
+        </p:nvSpPr>
+        <p:spPr>
+          <a:xfrm>
+            <a:off x="7251192" y="2944367"/>
+            <a:ext cx="292608" cy="292608"/>
+          </a:xfrm>
+          <a:prstGeom prst="ellipse">
+            <a:avLst/>
+          </a:prstGeom>
+          <a:solidFill>
+            <a:srgbClr val="10261B"/>
+          </a:solidFill>
+          <a:ln w="12700">
+            <a:solidFill>
+              <a:srgbClr val="4FBF87"/>
+            </a:solidFill>
+          </a:ln>
+          <a:effectLst/>
+        </p:spPr>
+        <p:style>
+          <a:lnRef idx="1">
+            <a:schemeClr val="accent1"/>
+          </a:lnRef>
+          <a:fillRef idx="3">
+            <a:schemeClr val="accent1"/>
+          </a:fillRef>
+          <a:effectRef idx="2">
+            <a:schemeClr val="accent1"/>
+          </a:effectRef>
+          <a:fontRef idx="minor">
+            <a:schemeClr val="lt1"/>
+          </a:fontRef>
+        </p:style>
+        <p:txBody>
+          <a:bodyPr lIns="0" tIns="0" rIns="0" bIns="0" rtlCol="0" anchor="ctr"/>
+          <a:lstStyle/>
+          <a:p>
+            <a:pPr algn="ctr"/>
+            <a:r>
+              <a:rPr sz="1300" b="1">
+                <a:solidFill>
+                  <a:srgbClr val="4FBF87"/>
+                </a:solidFill>
+                <a:latin typeface="Space Grotesk"/>
+              </a:rPr>
+              <a:t>✓</a:t>
+            </a:r>
+          </a:p>
+        </p:txBody>
+      </p:sp>
+      <p:sp>
+        <p:nvSpPr>
+          <p:cNvPr id="26" name="Rounded Rectangle 25"/>
+          <p:cNvSpPr/>
+          <p:nvPr/>
+        </p:nvSpPr>
+        <p:spPr>
+          <a:xfrm>
+            <a:off x="7872984" y="2734055"/>
+            <a:ext cx="3429000" cy="713232"/>
+          </a:xfrm>
+          <a:prstGeom prst="roundRect">
+            <a:avLst>
+              <a:gd name="adj" fmla="val 6000"/>
+            </a:avLst>
+          </a:prstGeom>
+          <a:solidFill>
+            <a:srgbClr val="101318"/>
+          </a:solidFill>
+          <a:ln w="12700">
+            <a:solidFill>
+              <a:srgbClr val="1D222B"/>
+            </a:solidFill>
+          </a:ln>
+          <a:effectLst/>
+        </p:spPr>
+        <p:style>
+          <a:lnRef idx="1">
+            <a:schemeClr val="accent1"/>
+          </a:lnRef>
+          <a:fillRef idx="3">
+            <a:schemeClr val="accent1"/>
+          </a:fillRef>
+          <a:effectRef idx="2">
+            <a:schemeClr val="accent1"/>
+          </a:effectRef>
+          <a:fontRef idx="minor">
+            <a:schemeClr val="lt1"/>
+          </a:fontRef>
+        </p:style>
+        <p:txBody>
+          <a:bodyPr rtlCol="0" anchor="ctr"/>
+          <a:lstStyle/>
+          <a:p>
+            <a:pPr algn="ctr"/>
+            <a:endParaRPr/>
+          </a:p>
+        </p:txBody>
+      </p:sp>
+      <p:sp>
+        <p:nvSpPr>
+          <p:cNvPr id="27" name="TextBox 26"/>
+          <p:cNvSpPr txBox="1"/>
+          <p:nvPr/>
+        </p:nvSpPr>
+        <p:spPr>
+          <a:xfrm>
+            <a:off x="8055864" y="2843783"/>
+            <a:ext cx="822960" cy="457200"/>
+          </a:xfrm>
+          <a:prstGeom prst="rect">
+            <a:avLst/>
+          </a:prstGeom>
+          <a:noFill/>
+        </p:spPr>
+        <p:txBody>
+          <a:bodyPr wrap="square" lIns="0" tIns="0" rIns="0" bIns="0" anchor="t">
+            <a:spAutoFit/>
+          </a:bodyPr>
+          <a:lstStyle/>
+          <a:p>
+            <a:pPr algn="l">
+              <a:lnSpc>
+                <a:spcPct val="115000"/>
+              </a:lnSpc>
+            </a:pPr>
+            <a:r>
+              <a:rPr sz="1500" b="1" i="0">
+                <a:solidFill>
+                  <a:srgbClr val="C9A45C"/>
+                </a:solidFill>
+                <a:latin typeface="JetBrains Mono"/>
+              </a:rPr>
+              <a:t>PG</a:t>
+            </a:r>
+          </a:p>
+        </p:txBody>
+      </p:sp>
+      <p:sp>
+        <p:nvSpPr>
+          <p:cNvPr id="28" name="TextBox 27"/>
+          <p:cNvSpPr txBox="1"/>
+          <p:nvPr/>
+        </p:nvSpPr>
+        <p:spPr>
+          <a:xfrm>
+            <a:off x="8833104" y="2807207"/>
+            <a:ext cx="1965960" cy="548640"/>
+          </a:xfrm>
+          <a:prstGeom prst="rect">
+            <a:avLst/>
+          </a:prstGeom>
+          <a:noFill/>
+        </p:spPr>
+        <p:txBody>
+          <a:bodyPr wrap="square" lIns="0" tIns="0" rIns="0" bIns="0" anchor="t">
+            <a:spAutoFit/>
+          </a:bodyPr>
+          <a:lstStyle/>
+          <a:p>
+            <a:pPr algn="l">
+              <a:lnSpc>
+                <a:spcPct val="105000"/>
+              </a:lnSpc>
+            </a:pPr>
+            <a:r>
+              <a:rPr sz="1150" b="0" i="0">
+                <a:solidFill>
+                  <a:srgbClr val="E7E9ED"/>
+                </a:solidFill>
+                <a:latin typeface="Space Grotesk"/>
+              </a:rPr>
+              <a:t>PostgreSQL 16 Flexible Server</a:t>
+            </a:r>
+          </a:p>
+        </p:txBody>
+      </p:sp>
+      <p:sp>
+        <p:nvSpPr>
+          <p:cNvPr id="29" name="Oval 28"/>
+          <p:cNvSpPr/>
+          <p:nvPr/>
+        </p:nvSpPr>
+        <p:spPr>
+          <a:xfrm>
+            <a:off x="10844784" y="2944367"/>
+            <a:ext cx="292608" cy="292608"/>
+          </a:xfrm>
+          <a:prstGeom prst="ellipse">
+            <a:avLst/>
+          </a:prstGeom>
+          <a:solidFill>
+            <a:srgbClr val="10261B"/>
+          </a:solidFill>
+          <a:ln w="12700">
+            <a:solidFill>
+              <a:srgbClr val="4FBF87"/>
+            </a:solidFill>
+          </a:ln>
+          <a:effectLst/>
+        </p:spPr>
+        <p:style>
+          <a:lnRef idx="1">
+            <a:schemeClr val="accent1"/>
+          </a:lnRef>
+          <a:fillRef idx="3">
+            <a:schemeClr val="accent1"/>
+          </a:fillRef>
+          <a:effectRef idx="2">
+            <a:schemeClr val="accent1"/>
+          </a:effectRef>
+          <a:fontRef idx="minor">
+            <a:schemeClr val="lt1"/>
+          </a:fontRef>
+        </p:style>
+        <p:txBody>
+          <a:bodyPr lIns="0" tIns="0" rIns="0" bIns="0" rtlCol="0" anchor="ctr"/>
+          <a:lstStyle/>
+          <a:p>
+            <a:pPr algn="ctr"/>
+            <a:r>
+              <a:rPr sz="1300" b="1">
+                <a:solidFill>
+                  <a:srgbClr val="4FBF87"/>
+                </a:solidFill>
+                <a:latin typeface="Space Grotesk"/>
+              </a:rPr>
+              <a:t>✓</a:t>
+            </a:r>
+          </a:p>
+        </p:txBody>
+      </p:sp>
+      <p:sp>
+        <p:nvSpPr>
+          <p:cNvPr id="30" name="Rounded Rectangle 29"/>
+          <p:cNvSpPr/>
+          <p:nvPr/>
+        </p:nvSpPr>
+        <p:spPr>
+          <a:xfrm>
+            <a:off x="685800" y="3593591"/>
+            <a:ext cx="3429000" cy="713232"/>
+          </a:xfrm>
+          <a:prstGeom prst="roundRect">
+            <a:avLst>
+              <a:gd name="adj" fmla="val 6000"/>
+            </a:avLst>
+          </a:prstGeom>
+          <a:solidFill>
+            <a:srgbClr val="101318"/>
+          </a:solidFill>
+          <a:ln w="12700">
+            <a:solidFill>
+              <a:srgbClr val="1D222B"/>
+            </a:solidFill>
+          </a:ln>
+          <a:effectLst/>
+        </p:spPr>
+        <p:style>
+          <a:lnRef idx="1">
+            <a:schemeClr val="accent1"/>
+          </a:lnRef>
+          <a:fillRef idx="3">
+            <a:schemeClr val="accent1"/>
+          </a:fillRef>
+          <a:effectRef idx="2">
+            <a:schemeClr val="accent1"/>
+          </a:effectRef>
+          <a:fontRef idx="minor">
+            <a:schemeClr val="lt1"/>
+          </a:fontRef>
+        </p:style>
+        <p:txBody>
+          <a:bodyPr rtlCol="0" anchor="ctr"/>
+          <a:lstStyle/>
+          <a:p>
+            <a:pPr algn="ctr"/>
+            <a:endParaRPr/>
+          </a:p>
+        </p:txBody>
+      </p:sp>
+      <p:sp>
+        <p:nvSpPr>
+          <p:cNvPr id="31" name="TextBox 30"/>
+          <p:cNvSpPr txBox="1"/>
+          <p:nvPr/>
+        </p:nvSpPr>
+        <p:spPr>
+          <a:xfrm>
+            <a:off x="868680" y="3703319"/>
+            <a:ext cx="822960" cy="457200"/>
+          </a:xfrm>
+          <a:prstGeom prst="rect">
+            <a:avLst/>
+          </a:prstGeom>
+          <a:noFill/>
+        </p:spPr>
+        <p:txBody>
+          <a:bodyPr wrap="square" lIns="0" tIns="0" rIns="0" bIns="0" anchor="t">
+            <a:spAutoFit/>
+          </a:bodyPr>
+          <a:lstStyle/>
+          <a:p>
+            <a:pPr algn="l">
+              <a:lnSpc>
+                <a:spcPct val="115000"/>
+              </a:lnSpc>
+            </a:pPr>
+            <a:r>
+              <a:rPr sz="1500" b="1" i="0">
+                <a:solidFill>
+                  <a:srgbClr val="C9A45C"/>
+                </a:solidFill>
+                <a:latin typeface="JetBrains Mono"/>
+              </a:rPr>
+              <a:t>REDIS</a:t>
+            </a:r>
+          </a:p>
+        </p:txBody>
+      </p:sp>
+      <p:sp>
+        <p:nvSpPr>
+          <p:cNvPr id="32" name="TextBox 31"/>
+          <p:cNvSpPr txBox="1"/>
+          <p:nvPr/>
+        </p:nvSpPr>
+        <p:spPr>
+          <a:xfrm>
+            <a:off x="1645920" y="3666743"/>
+            <a:ext cx="1965960" cy="548640"/>
+          </a:xfrm>
+          <a:prstGeom prst="rect">
+            <a:avLst/>
+          </a:prstGeom>
+          <a:noFill/>
+        </p:spPr>
+        <p:txBody>
+          <a:bodyPr wrap="square" lIns="0" tIns="0" rIns="0" bIns="0" anchor="t">
+            <a:spAutoFit/>
+          </a:bodyPr>
+          <a:lstStyle/>
+          <a:p>
+            <a:pPr algn="l">
+              <a:lnSpc>
+                <a:spcPct val="105000"/>
+              </a:lnSpc>
+            </a:pPr>
+            <a:r>
+              <a:rPr sz="1150" b="0" i="0">
+                <a:solidFill>
+                  <a:srgbClr val="E7E9ED"/>
+                </a:solidFill>
+                <a:latin typeface="Space Grotesk"/>
+              </a:rPr>
+              <a:t>Redis gestionado (Upstash, free tier)</a:t>
+            </a:r>
+          </a:p>
+        </p:txBody>
+      </p:sp>
+      <p:sp>
+        <p:nvSpPr>
+          <p:cNvPr id="33" name="Oval 32"/>
+          <p:cNvSpPr/>
+          <p:nvPr/>
+        </p:nvSpPr>
+        <p:spPr>
+          <a:xfrm>
+            <a:off x="3657600" y="3803903"/>
+            <a:ext cx="292608" cy="292608"/>
+          </a:xfrm>
+          <a:prstGeom prst="ellipse">
+            <a:avLst/>
+          </a:prstGeom>
+          <a:solidFill>
+            <a:srgbClr val="10261B"/>
+          </a:solidFill>
+          <a:ln w="12700">
+            <a:solidFill>
+              <a:srgbClr val="4FBF87"/>
+            </a:solidFill>
+          </a:ln>
+          <a:effectLst/>
+        </p:spPr>
+        <p:style>
+          <a:lnRef idx="1">
+            <a:schemeClr val="accent1"/>
+          </a:lnRef>
+          <a:fillRef idx="3">
+            <a:schemeClr val="accent1"/>
+          </a:fillRef>
+          <a:effectRef idx="2">
+            <a:schemeClr val="accent1"/>
+          </a:effectRef>
+          <a:fontRef idx="minor">
+            <a:schemeClr val="lt1"/>
+          </a:fontRef>
+        </p:style>
+        <p:txBody>
+          <a:bodyPr lIns="0" tIns="0" rIns="0" bIns="0" rtlCol="0" anchor="ctr"/>
+          <a:lstStyle/>
+          <a:p>
+            <a:pPr algn="ctr"/>
+            <a:r>
+              <a:rPr sz="1300" b="1">
+                <a:solidFill>
+                  <a:srgbClr val="4FBF87"/>
+                </a:solidFill>
+                <a:latin typeface="Space Grotesk"/>
+              </a:rPr>
+              <a:t>✓</a:t>
+            </a:r>
+          </a:p>
+        </p:txBody>
+      </p:sp>
+      <p:sp>
+        <p:nvSpPr>
+          <p:cNvPr id="34" name="Rounded Rectangle 33"/>
+          <p:cNvSpPr/>
+          <p:nvPr/>
+        </p:nvSpPr>
+        <p:spPr>
+          <a:xfrm>
+            <a:off x="4279392" y="3593591"/>
+            <a:ext cx="3429000" cy="713232"/>
+          </a:xfrm>
+          <a:prstGeom prst="roundRect">
+            <a:avLst>
+              <a:gd name="adj" fmla="val 6000"/>
+            </a:avLst>
+          </a:prstGeom>
+          <a:solidFill>
+            <a:srgbClr val="101318"/>
+          </a:solidFill>
+          <a:ln w="12700">
+            <a:solidFill>
+              <a:srgbClr val="1D222B"/>
+            </a:solidFill>
+          </a:ln>
+          <a:effectLst/>
+        </p:spPr>
+        <p:style>
+          <a:lnRef idx="1">
+            <a:schemeClr val="accent1"/>
+          </a:lnRef>
+          <a:fillRef idx="3">
+            <a:schemeClr val="accent1"/>
+          </a:fillRef>
+          <a:effectRef idx="2">
+            <a:schemeClr val="accent1"/>
+          </a:effectRef>
+          <a:fontRef idx="minor">
+            <a:schemeClr val="lt1"/>
+          </a:fontRef>
+        </p:style>
+        <p:txBody>
+          <a:bodyPr rtlCol="0" anchor="ctr"/>
+          <a:lstStyle/>
+          <a:p>
+            <a:pPr algn="ctr"/>
+            <a:endParaRPr/>
+          </a:p>
+        </p:txBody>
+      </p:sp>
+      <p:sp>
+        <p:nvSpPr>
+          <p:cNvPr id="35" name="TextBox 34"/>
+          <p:cNvSpPr txBox="1"/>
+          <p:nvPr/>
+        </p:nvSpPr>
+        <p:spPr>
+          <a:xfrm>
+            <a:off x="4462272" y="3703319"/>
+            <a:ext cx="822960" cy="457200"/>
+          </a:xfrm>
+          <a:prstGeom prst="rect">
+            <a:avLst/>
+          </a:prstGeom>
+          <a:noFill/>
+        </p:spPr>
+        <p:txBody>
+          <a:bodyPr wrap="square" lIns="0" tIns="0" rIns="0" bIns="0" anchor="t">
+            <a:spAutoFit/>
+          </a:bodyPr>
+          <a:lstStyle/>
+          <a:p>
+            <a:pPr algn="l">
+              <a:lnSpc>
+                <a:spcPct val="115000"/>
+              </a:lnSpc>
+            </a:pPr>
+            <a:r>
+              <a:rPr sz="1500" b="1" i="0">
+                <a:solidFill>
+                  <a:srgbClr val="C9A45C"/>
+                </a:solidFill>
+                <a:latin typeface="JetBrains Mono"/>
+              </a:rPr>
+              <a:t>GHCR</a:t>
+            </a:r>
+          </a:p>
+        </p:txBody>
+      </p:sp>
+      <p:sp>
+        <p:nvSpPr>
+          <p:cNvPr id="36" name="TextBox 35"/>
+          <p:cNvSpPr txBox="1"/>
+          <p:nvPr/>
+        </p:nvSpPr>
+        <p:spPr>
+          <a:xfrm>
+            <a:off x="5239512" y="3666743"/>
+            <a:ext cx="1965960" cy="548640"/>
+          </a:xfrm>
+          <a:prstGeom prst="rect">
+            <a:avLst/>
+          </a:prstGeom>
+          <a:noFill/>
+        </p:spPr>
+        <p:txBody>
+          <a:bodyPr wrap="square" lIns="0" tIns="0" rIns="0" bIns="0" anchor="t">
+            <a:spAutoFit/>
+          </a:bodyPr>
+          <a:lstStyle/>
+          <a:p>
+            <a:pPr algn="l">
+              <a:lnSpc>
+                <a:spcPct val="105000"/>
+              </a:lnSpc>
+            </a:pPr>
+            <a:r>
+              <a:rPr sz="1150" b="0" i="0">
+                <a:solidFill>
+                  <a:srgbClr val="E7E9ED"/>
+                </a:solidFill>
+                <a:latin typeface="Space Grotesk"/>
+              </a:rPr>
+              <a:t>Imágenes Docker públicas</a:t>
+            </a:r>
+          </a:p>
+        </p:txBody>
+      </p:sp>
+      <p:sp>
+        <p:nvSpPr>
+          <p:cNvPr id="37" name="Oval 36"/>
+          <p:cNvSpPr/>
+          <p:nvPr/>
+        </p:nvSpPr>
+        <p:spPr>
+          <a:xfrm>
+            <a:off x="7251192" y="3803903"/>
+            <a:ext cx="292608" cy="292608"/>
+          </a:xfrm>
+          <a:prstGeom prst="ellipse">
+            <a:avLst/>
+          </a:prstGeom>
+          <a:solidFill>
+            <a:srgbClr val="10261B"/>
+          </a:solidFill>
+          <a:ln w="12700">
+            <a:solidFill>
+              <a:srgbClr val="4FBF87"/>
+            </a:solidFill>
+          </a:ln>
+          <a:effectLst/>
+        </p:spPr>
+        <p:style>
+          <a:lnRef idx="1">
+            <a:schemeClr val="accent1"/>
+          </a:lnRef>
+          <a:fillRef idx="3">
+            <a:schemeClr val="accent1"/>
+          </a:fillRef>
+          <a:effectRef idx="2">
+            <a:schemeClr val="accent1"/>
+          </a:effectRef>
+          <a:fontRef idx="minor">
+            <a:schemeClr val="lt1"/>
+          </a:fontRef>
+        </p:style>
+        <p:txBody>
+          <a:bodyPr lIns="0" tIns="0" rIns="0" bIns="0" rtlCol="0" anchor="ctr"/>
+          <a:lstStyle/>
+          <a:p>
+            <a:pPr algn="ctr"/>
+            <a:r>
+              <a:rPr sz="1300" b="1">
+                <a:solidFill>
+                  <a:srgbClr val="4FBF87"/>
+                </a:solidFill>
+                <a:latin typeface="Space Grotesk"/>
+              </a:rPr>
+              <a:t>✓</a:t>
+            </a:r>
+          </a:p>
+        </p:txBody>
+      </p:sp>
+      <p:sp>
+        <p:nvSpPr>
+          <p:cNvPr id="38" name="Rounded Rectangle 37"/>
+          <p:cNvSpPr/>
+          <p:nvPr/>
+        </p:nvSpPr>
+        <p:spPr>
+          <a:xfrm>
+            <a:off x="7872984" y="3593591"/>
+            <a:ext cx="3429000" cy="713232"/>
+          </a:xfrm>
+          <a:prstGeom prst="roundRect">
+            <a:avLst>
+              <a:gd name="adj" fmla="val 6000"/>
+            </a:avLst>
+          </a:prstGeom>
+          <a:solidFill>
+            <a:srgbClr val="101318"/>
+          </a:solidFill>
+          <a:ln w="12700">
+            <a:solidFill>
+              <a:srgbClr val="1D222B"/>
+            </a:solidFill>
+          </a:ln>
+          <a:effectLst/>
+        </p:spPr>
+        <p:style>
+          <a:lnRef idx="1">
+            <a:schemeClr val="accent1"/>
+          </a:lnRef>
+          <a:fillRef idx="3">
+            <a:schemeClr val="accent1"/>
+          </a:fillRef>
+          <a:effectRef idx="2">
+            <a:schemeClr val="accent1"/>
+          </a:effectRef>
+          <a:fontRef idx="minor">
+            <a:schemeClr val="lt1"/>
+          </a:fontRef>
+        </p:style>
+        <p:txBody>
+          <a:bodyPr rtlCol="0" anchor="ctr"/>
+          <a:lstStyle/>
+          <a:p>
+            <a:pPr algn="ctr"/>
+            <a:endParaRPr/>
+          </a:p>
+        </p:txBody>
+      </p:sp>
+      <p:sp>
+        <p:nvSpPr>
+          <p:cNvPr id="39" name="TextBox 38"/>
+          <p:cNvSpPr txBox="1"/>
+          <p:nvPr/>
+        </p:nvSpPr>
+        <p:spPr>
+          <a:xfrm>
+            <a:off x="8055864" y="3703319"/>
+            <a:ext cx="822960" cy="457200"/>
+          </a:xfrm>
+          <a:prstGeom prst="rect">
+            <a:avLst/>
+          </a:prstGeom>
+          <a:noFill/>
+        </p:spPr>
+        <p:txBody>
+          <a:bodyPr wrap="square" lIns="0" tIns="0" rIns="0" bIns="0" anchor="t">
+            <a:spAutoFit/>
+          </a:bodyPr>
+          <a:lstStyle/>
+          <a:p>
+            <a:pPr algn="l">
+              <a:lnSpc>
+                <a:spcPct val="115000"/>
+              </a:lnSpc>
+            </a:pPr>
+            <a:r>
+              <a:rPr sz="1500" b="1" i="0">
+                <a:solidFill>
+                  <a:srgbClr val="C9A45C"/>
+                </a:solidFill>
+                <a:latin typeface="JetBrains Mono"/>
+              </a:rPr>
+              <a:t>TLS</a:t>
+            </a:r>
+          </a:p>
+        </p:txBody>
+      </p:sp>
+      <p:sp>
+        <p:nvSpPr>
+          <p:cNvPr id="40" name="TextBox 39"/>
+          <p:cNvSpPr txBox="1"/>
+          <p:nvPr/>
+        </p:nvSpPr>
+        <p:spPr>
+          <a:xfrm>
+            <a:off x="8833104" y="3666743"/>
+            <a:ext cx="1965960" cy="548640"/>
+          </a:xfrm>
+          <a:prstGeom prst="rect">
+            <a:avLst/>
+          </a:prstGeom>
+          <a:noFill/>
+        </p:spPr>
+        <p:txBody>
+          <a:bodyPr wrap="square" lIns="0" tIns="0" rIns="0" bIns="0" anchor="t">
+            <a:spAutoFit/>
+          </a:bodyPr>
+          <a:lstStyle/>
+          <a:p>
+            <a:pPr algn="l">
+              <a:lnSpc>
+                <a:spcPct val="105000"/>
+              </a:lnSpc>
+            </a:pPr>
+            <a:r>
+              <a:rPr sz="1150" b="0" i="0">
+                <a:solidFill>
+                  <a:srgbClr val="E7E9ED"/>
+                </a:solidFill>
+                <a:latin typeface="Space Grotesk"/>
+              </a:rPr>
+              <a:t>HTTPS en todos los servicios</a:t>
+            </a:r>
+          </a:p>
+        </p:txBody>
+      </p:sp>
+      <p:sp>
+        <p:nvSpPr>
+          <p:cNvPr id="41" name="Oval 40"/>
+          <p:cNvSpPr/>
+          <p:nvPr/>
+        </p:nvSpPr>
+        <p:spPr>
+          <a:xfrm>
+            <a:off x="10844784" y="3803903"/>
+            <a:ext cx="292608" cy="292608"/>
+          </a:xfrm>
+          <a:prstGeom prst="ellipse">
+            <a:avLst/>
+          </a:prstGeom>
+          <a:solidFill>
+            <a:srgbClr val="10261B"/>
+          </a:solidFill>
+          <a:ln w="12700">
+            <a:solidFill>
+              <a:srgbClr val="4FBF87"/>
+            </a:solidFill>
+          </a:ln>
+          <a:effectLst/>
+        </p:spPr>
+        <p:style>
+          <a:lnRef idx="1">
+            <a:schemeClr val="accent1"/>
+          </a:lnRef>
+          <a:fillRef idx="3">
+            <a:schemeClr val="accent1"/>
+          </a:fillRef>
+          <a:effectRef idx="2">
+            <a:schemeClr val="accent1"/>
+          </a:effectRef>
+          <a:fontRef idx="minor">
+            <a:schemeClr val="lt1"/>
+          </a:fontRef>
+        </p:style>
+        <p:txBody>
+          <a:bodyPr lIns="0" tIns="0" rIns="0" bIns="0" rtlCol="0" anchor="ctr"/>
+          <a:lstStyle/>
+          <a:p>
+            <a:pPr algn="ctr"/>
+            <a:r>
+              <a:rPr sz="1300" b="1">
+                <a:solidFill>
+                  <a:srgbClr val="4FBF87"/>
+                </a:solidFill>
+                <a:latin typeface="Space Grotesk"/>
+              </a:rPr>
+              <a:t>✓</a:t>
+            </a:r>
+          </a:p>
+        </p:txBody>
+      </p:sp>
+      <p:sp>
+        <p:nvSpPr>
+          <p:cNvPr id="42" name="Rounded Rectangle 41"/>
+          <p:cNvSpPr/>
+          <p:nvPr/>
+        </p:nvSpPr>
+        <p:spPr>
+          <a:xfrm>
+            <a:off x="685800" y="4453127"/>
+            <a:ext cx="3429000" cy="713232"/>
+          </a:xfrm>
+          <a:prstGeom prst="roundRect">
+            <a:avLst>
+              <a:gd name="adj" fmla="val 6000"/>
+            </a:avLst>
+          </a:prstGeom>
+          <a:solidFill>
+            <a:srgbClr val="101318"/>
+          </a:solidFill>
+          <a:ln w="12700">
+            <a:solidFill>
+              <a:srgbClr val="1D222B"/>
+            </a:solidFill>
+          </a:ln>
+          <a:effectLst/>
+        </p:spPr>
+        <p:style>
+          <a:lnRef idx="1">
+            <a:schemeClr val="accent1"/>
+          </a:lnRef>
+          <a:fillRef idx="3">
+            <a:schemeClr val="accent1"/>
+          </a:fillRef>
+          <a:effectRef idx="2">
+            <a:schemeClr val="accent1"/>
+          </a:effectRef>
+          <a:fontRef idx="minor">
+            <a:schemeClr val="lt1"/>
+          </a:fontRef>
+        </p:style>
+        <p:txBody>
+          <a:bodyPr rtlCol="0" anchor="ctr"/>
+          <a:lstStyle/>
+          <a:p>
+            <a:pPr algn="ctr"/>
+            <a:endParaRPr/>
+          </a:p>
+        </p:txBody>
+      </p:sp>
+      <p:sp>
+        <p:nvSpPr>
+          <p:cNvPr id="43" name="TextBox 42"/>
+          <p:cNvSpPr txBox="1"/>
+          <p:nvPr/>
+        </p:nvSpPr>
+        <p:spPr>
+          <a:xfrm>
+            <a:off x="868680" y="4562855"/>
+            <a:ext cx="822960" cy="457200"/>
+          </a:xfrm>
+          <a:prstGeom prst="rect">
+            <a:avLst/>
+          </a:prstGeom>
+          <a:noFill/>
+        </p:spPr>
+        <p:txBody>
+          <a:bodyPr wrap="square" lIns="0" tIns="0" rIns="0" bIns="0" anchor="t">
+            <a:spAutoFit/>
+          </a:bodyPr>
+          <a:lstStyle/>
+          <a:p>
+            <a:pPr algn="l">
+              <a:lnSpc>
+                <a:spcPct val="115000"/>
+              </a:lnSpc>
+            </a:pPr>
+            <a:r>
+              <a:rPr sz="1500" b="1" i="0">
+                <a:solidFill>
+                  <a:srgbClr val="C9A45C"/>
+                </a:solidFill>
+                <a:latin typeface="JetBrains Mono"/>
+              </a:rPr>
+              <a:t>CSRF</a:t>
+            </a:r>
+          </a:p>
+        </p:txBody>
+      </p:sp>
+      <p:sp>
+        <p:nvSpPr>
+          <p:cNvPr id="44" name="TextBox 43"/>
+          <p:cNvSpPr txBox="1"/>
+          <p:nvPr/>
+        </p:nvSpPr>
+        <p:spPr>
+          <a:xfrm>
+            <a:off x="1645920" y="4526279"/>
+            <a:ext cx="1965960" cy="548640"/>
+          </a:xfrm>
+          <a:prstGeom prst="rect">
+            <a:avLst/>
+          </a:prstGeom>
+          <a:noFill/>
+        </p:spPr>
+        <p:txBody>
+          <a:bodyPr wrap="square" lIns="0" tIns="0" rIns="0" bIns="0" anchor="t">
+            <a:spAutoFit/>
+          </a:bodyPr>
+          <a:lstStyle/>
+          <a:p>
+            <a:pPr algn="l">
+              <a:lnSpc>
+                <a:spcPct val="105000"/>
+              </a:lnSpc>
+            </a:pPr>
+            <a:r>
+              <a:rPr sz="1150" b="0" i="0">
+                <a:solidFill>
+                  <a:srgbClr val="E7E9ED"/>
+                </a:solidFill>
+                <a:latin typeface="Space Grotesk"/>
+              </a:rPr>
+              <a:t>Token CSRF en body de login (dominios cruzados)</a:t>
+            </a:r>
+          </a:p>
+        </p:txBody>
+      </p:sp>
+      <p:sp>
+        <p:nvSpPr>
+          <p:cNvPr id="45" name="Oval 44"/>
+          <p:cNvSpPr/>
+          <p:nvPr/>
+        </p:nvSpPr>
+        <p:spPr>
+          <a:xfrm>
+            <a:off x="3657600" y="4663439"/>
+            <a:ext cx="292608" cy="292608"/>
+          </a:xfrm>
+          <a:prstGeom prst="ellipse">
+            <a:avLst/>
+          </a:prstGeom>
+          <a:solidFill>
+            <a:srgbClr val="10261B"/>
+          </a:solidFill>
+          <a:ln w="12700">
+            <a:solidFill>
+              <a:srgbClr val="4FBF87"/>
+            </a:solidFill>
+          </a:ln>
+          <a:effectLst/>
+        </p:spPr>
+        <p:style>
+          <a:lnRef idx="1">
+            <a:schemeClr val="accent1"/>
+          </a:lnRef>
+          <a:fillRef idx="3">
+            <a:schemeClr val="accent1"/>
+          </a:fillRef>
+          <a:effectRef idx="2">
+            <a:schemeClr val="accent1"/>
+          </a:effectRef>
+          <a:fontRef idx="minor">
+            <a:schemeClr val="lt1"/>
+          </a:fontRef>
+        </p:style>
+        <p:txBody>
+          <a:bodyPr lIns="0" tIns="0" rIns="0" bIns="0" rtlCol="0" anchor="ctr"/>
+          <a:lstStyle/>
+          <a:p>
+            <a:pPr algn="ctr"/>
+            <a:r>
+              <a:rPr sz="1300" b="1">
+                <a:solidFill>
+                  <a:srgbClr val="4FBF87"/>
+                </a:solidFill>
+                <a:latin typeface="Space Grotesk"/>
+              </a:rPr>
+              <a:t>✓</a:t>
+            </a:r>
+          </a:p>
+        </p:txBody>
+      </p:sp>
+      <p:sp>
+        <p:nvSpPr>
+          <p:cNvPr id="46" name="Rounded Rectangle 45"/>
+          <p:cNvSpPr/>
+          <p:nvPr/>
+        </p:nvSpPr>
+        <p:spPr>
+          <a:xfrm>
+            <a:off x="4279392" y="4453127"/>
+            <a:ext cx="3429000" cy="713232"/>
+          </a:xfrm>
+          <a:prstGeom prst="roundRect">
+            <a:avLst>
+              <a:gd name="adj" fmla="val 6000"/>
+            </a:avLst>
+          </a:prstGeom>
+          <a:solidFill>
+            <a:srgbClr val="101318"/>
+          </a:solidFill>
+          <a:ln w="12700">
+            <a:solidFill>
+              <a:srgbClr val="1D222B"/>
+            </a:solidFill>
+          </a:ln>
+          <a:effectLst/>
+        </p:spPr>
+        <p:style>
+          <a:lnRef idx="1">
+            <a:schemeClr val="accent1"/>
+          </a:lnRef>
+          <a:fillRef idx="3">
+            <a:schemeClr val="accent1"/>
+          </a:fillRef>
+          <a:effectRef idx="2">
+            <a:schemeClr val="accent1"/>
+          </a:effectRef>
+          <a:fontRef idx="minor">
+            <a:schemeClr val="lt1"/>
+          </a:fontRef>
+        </p:style>
+        <p:txBody>
+          <a:bodyPr rtlCol="0" anchor="ctr"/>
+          <a:lstStyle/>
+          <a:p>
+            <a:pPr algn="ctr"/>
+            <a:endParaRPr/>
+          </a:p>
+        </p:txBody>
+      </p:sp>
+      <p:sp>
+        <p:nvSpPr>
+          <p:cNvPr id="47" name="TextBox 46"/>
+          <p:cNvSpPr txBox="1"/>
+          <p:nvPr/>
+        </p:nvSpPr>
+        <p:spPr>
+          <a:xfrm>
+            <a:off x="4462272" y="4562855"/>
+            <a:ext cx="822960" cy="457200"/>
+          </a:xfrm>
+          <a:prstGeom prst="rect">
+            <a:avLst/>
+          </a:prstGeom>
+          <a:noFill/>
+        </p:spPr>
+        <p:txBody>
+          <a:bodyPr wrap="square" lIns="0" tIns="0" rIns="0" bIns="0" anchor="t">
+            <a:spAutoFit/>
+          </a:bodyPr>
+          <a:lstStyle/>
+          <a:p>
+            <a:pPr algn="l">
+              <a:lnSpc>
+                <a:spcPct val="115000"/>
+              </a:lnSpc>
+            </a:pPr>
+            <a:r>
+              <a:rPr sz="1500" b="1" i="0">
+                <a:solidFill>
+                  <a:srgbClr val="C9A45C"/>
+                </a:solidFill>
+                <a:latin typeface="JetBrains Mono"/>
+              </a:rPr>
+              <a:t>MAN</a:t>
+            </a:r>
+          </a:p>
+        </p:txBody>
+      </p:sp>
+      <p:sp>
+        <p:nvSpPr>
+          <p:cNvPr id="48" name="TextBox 47"/>
+          <p:cNvSpPr txBox="1"/>
+          <p:nvPr/>
+        </p:nvSpPr>
+        <p:spPr>
+          <a:xfrm>
+            <a:off x="5239512" y="4526279"/>
+            <a:ext cx="1965960" cy="548640"/>
+          </a:xfrm>
+          <a:prstGeom prst="rect">
+            <a:avLst/>
+          </a:prstGeom>
+          <a:noFill/>
+        </p:spPr>
+        <p:txBody>
+          <a:bodyPr wrap="square" lIns="0" tIns="0" rIns="0" bIns="0" anchor="t">
+            <a:spAutoFit/>
+          </a:bodyPr>
+          <a:lstStyle/>
+          <a:p>
+            <a:pPr algn="l">
+              <a:lnSpc>
+                <a:spcPct val="105000"/>
+              </a:lnSpc>
+            </a:pPr>
+            <a:r>
+              <a:rPr sz="1150" b="0" i="0">
+                <a:solidFill>
+                  <a:srgbClr val="E7E9ED"/>
+                </a:solidFill>
+                <a:latin typeface="Space Grotesk"/>
+              </a:rPr>
+              <a:t>Despliegue manual, sin CI/CD (Spec 00d §5)</a:t>
+            </a:r>
+          </a:p>
+        </p:txBody>
+      </p:sp>
+      <p:sp>
+        <p:nvSpPr>
+          <p:cNvPr id="49" name="Oval 48"/>
+          <p:cNvSpPr/>
+          <p:nvPr/>
+        </p:nvSpPr>
+        <p:spPr>
+          <a:xfrm>
+            <a:off x="7251192" y="4663439"/>
+            <a:ext cx="292608" cy="292608"/>
+          </a:xfrm>
+          <a:prstGeom prst="ellipse">
+            <a:avLst/>
+          </a:prstGeom>
+          <a:solidFill>
+            <a:srgbClr val="10261B"/>
+          </a:solidFill>
+          <a:ln w="12700">
+            <a:solidFill>
+              <a:srgbClr val="4FBF87"/>
+            </a:solidFill>
+          </a:ln>
+          <a:effectLst/>
+        </p:spPr>
+        <p:style>
+          <a:lnRef idx="1">
+            <a:schemeClr val="accent1"/>
+          </a:lnRef>
+          <a:fillRef idx="3">
+            <a:schemeClr val="accent1"/>
+          </a:fillRef>
+          <a:effectRef idx="2">
+            <a:schemeClr val="accent1"/>
+          </a:effectRef>
+          <a:fontRef idx="minor">
+            <a:schemeClr val="lt1"/>
+          </a:fontRef>
+        </p:style>
+        <p:txBody>
+          <a:bodyPr lIns="0" tIns="0" rIns="0" bIns="0" rtlCol="0" anchor="ctr"/>
+          <a:lstStyle/>
+          <a:p>
+            <a:pPr algn="ctr"/>
+            <a:r>
+              <a:rPr sz="1300" b="1">
+                <a:solidFill>
+                  <a:srgbClr val="4FBF87"/>
+                </a:solidFill>
+                <a:latin typeface="Space Grotesk"/>
+              </a:rPr>
+              <a:t>✓</a:t>
+            </a:r>
+          </a:p>
+        </p:txBody>
+      </p:sp>
+      <p:sp>
+        <p:nvSpPr>
+          <p:cNvPr id="50" name="Rounded Rectangle 49"/>
+          <p:cNvSpPr/>
+          <p:nvPr/>
+        </p:nvSpPr>
+        <p:spPr>
+          <a:xfrm>
+            <a:off x="7872984" y="4453127"/>
+            <a:ext cx="3429000" cy="713232"/>
+          </a:xfrm>
+          <a:prstGeom prst="roundRect">
+            <a:avLst>
+              <a:gd name="adj" fmla="val 6000"/>
+            </a:avLst>
+          </a:prstGeom>
+          <a:solidFill>
+            <a:srgbClr val="101318"/>
+          </a:solidFill>
+          <a:ln w="12700">
+            <a:solidFill>
+              <a:srgbClr val="1D222B"/>
+            </a:solidFill>
+          </a:ln>
+          <a:effectLst/>
+        </p:spPr>
+        <p:style>
+          <a:lnRef idx="1">
+            <a:schemeClr val="accent1"/>
+          </a:lnRef>
+          <a:fillRef idx="3">
+            <a:schemeClr val="accent1"/>
+          </a:fillRef>
+          <a:effectRef idx="2">
+            <a:schemeClr val="accent1"/>
+          </a:effectRef>
+          <a:fontRef idx="minor">
+            <a:schemeClr val="lt1"/>
+          </a:fontRef>
+        </p:style>
+        <p:txBody>
+          <a:bodyPr rtlCol="0" anchor="ctr"/>
+          <a:lstStyle/>
+          <a:p>
+            <a:pPr algn="ctr"/>
+            <a:endParaRPr/>
+          </a:p>
+        </p:txBody>
+      </p:sp>
+      <p:sp>
+        <p:nvSpPr>
+          <p:cNvPr id="51" name="TextBox 50"/>
+          <p:cNvSpPr txBox="1"/>
+          <p:nvPr/>
+        </p:nvSpPr>
+        <p:spPr>
+          <a:xfrm>
+            <a:off x="8055864" y="4562855"/>
+            <a:ext cx="822960" cy="457200"/>
+          </a:xfrm>
+          <a:prstGeom prst="rect">
+            <a:avLst/>
+          </a:prstGeom>
+          <a:noFill/>
+        </p:spPr>
+        <p:txBody>
+          <a:bodyPr wrap="square" lIns="0" tIns="0" rIns="0" bIns="0" anchor="t">
+            <a:spAutoFit/>
+          </a:bodyPr>
+          <a:lstStyle/>
+          <a:p>
+            <a:pPr algn="l">
+              <a:lnSpc>
+                <a:spcPct val="115000"/>
+              </a:lnSpc>
+            </a:pPr>
+            <a:r>
+              <a:rPr sz="1500" b="1" i="0">
+                <a:solidFill>
+                  <a:srgbClr val="C9A45C"/>
+                </a:solidFill>
+                <a:latin typeface="JetBrains Mono"/>
+              </a:rPr>
+              <a:t>€</a:t>
+            </a:r>
+          </a:p>
+        </p:txBody>
+      </p:sp>
+      <p:sp>
+        <p:nvSpPr>
+          <p:cNvPr id="52" name="TextBox 51"/>
+          <p:cNvSpPr txBox="1"/>
+          <p:nvPr/>
+        </p:nvSpPr>
+        <p:spPr>
+          <a:xfrm>
+            <a:off x="8833104" y="4526279"/>
+            <a:ext cx="1965960" cy="548640"/>
+          </a:xfrm>
+          <a:prstGeom prst="rect">
+            <a:avLst/>
+          </a:prstGeom>
+          <a:noFill/>
+        </p:spPr>
+        <p:txBody>
+          <a:bodyPr wrap="square" lIns="0" tIns="0" rIns="0" bIns="0" anchor="t">
+            <a:spAutoFit/>
+          </a:bodyPr>
+          <a:lstStyle/>
+          <a:p>
+            <a:pPr algn="l">
+              <a:lnSpc>
+                <a:spcPct val="105000"/>
+              </a:lnSpc>
+            </a:pPr>
+            <a:r>
+              <a:rPr sz="1150" b="0" i="0">
+                <a:solidFill>
+                  <a:srgbClr val="E7E9ED"/>
+                </a:solidFill>
+                <a:latin typeface="Space Grotesk"/>
+              </a:rPr>
+              <a:t>~20-21 €/mes</a:t>
+            </a:r>
+          </a:p>
+        </p:txBody>
+      </p:sp>
+      <p:sp>
+        <p:nvSpPr>
+          <p:cNvPr id="53" name="Oval 52"/>
+          <p:cNvSpPr/>
+          <p:nvPr/>
+        </p:nvSpPr>
+        <p:spPr>
+          <a:xfrm>
+            <a:off x="10844784" y="4663439"/>
+            <a:ext cx="292608" cy="292608"/>
+          </a:xfrm>
+          <a:prstGeom prst="ellipse">
+            <a:avLst/>
+          </a:prstGeom>
+          <a:solidFill>
+            <a:srgbClr val="10261B"/>
+          </a:solidFill>
+          <a:ln w="12700">
+            <a:solidFill>
+              <a:srgbClr val="4FBF87"/>
+            </a:solidFill>
+          </a:ln>
+          <a:effectLst/>
+        </p:spPr>
+        <p:style>
+          <a:lnRef idx="1">
+            <a:schemeClr val="accent1"/>
+          </a:lnRef>
+          <a:fillRef idx="3">
+            <a:schemeClr val="accent1"/>
+          </a:fillRef>
+          <a:effectRef idx="2">
+            <a:schemeClr val="accent1"/>
+          </a:effectRef>
+          <a:fontRef idx="minor">
+            <a:schemeClr val="lt1"/>
+          </a:fontRef>
+        </p:style>
+        <p:txBody>
+          <a:bodyPr lIns="0" tIns="0" rIns="0" bIns="0" rtlCol="0" anchor="ctr"/>
+          <a:lstStyle/>
+          <a:p>
+            <a:pPr algn="ctr"/>
+            <a:r>
+              <a:rPr sz="1300" b="1">
+                <a:solidFill>
+                  <a:srgbClr val="4FBF87"/>
+                </a:solidFill>
+                <a:latin typeface="Space Grotesk"/>
+              </a:rPr>
+              <a:t>✓</a:t>
+            </a:r>
+          </a:p>
+        </p:txBody>
+      </p:sp>
+      <p:sp>
+        <p:nvSpPr>
+          <p:cNvPr id="54" name="TextBox 53"/>
+          <p:cNvSpPr txBox="1"/>
+          <p:nvPr/>
+        </p:nvSpPr>
+        <p:spPr>
+          <a:xfrm>
+            <a:off x="685800" y="5358383"/>
+            <a:ext cx="10241280" cy="365760"/>
+          </a:xfrm>
+          <a:prstGeom prst="rect">
+            <a:avLst/>
+          </a:prstGeom>
+          <a:noFill/>
+        </p:spPr>
+        <p:txBody>
+          <a:bodyPr wrap="square" lIns="0" tIns="0" rIns="0" bIns="0" anchor="t">
+            <a:spAutoFit/>
+          </a:bodyPr>
+          <a:lstStyle/>
+          <a:p>
+            <a:pPr algn="l">
+              <a:lnSpc>
+                <a:spcPct val="115000"/>
+              </a:lnSpc>
+            </a:pPr>
+            <a:r>
+              <a:rPr sz="1150" b="0" i="0">
+                <a:solidFill>
+                  <a:srgbClr val="5C6472"/>
+                </a:solidFill>
+                <a:latin typeface="JetBrains Mono"/>
+              </a:rPr>
+              <a:t>Bug real resuelto en producción: la cookie CSRF era invisible entre frontend y backend (subdominios distintos) — runbook completo en Changeset C09.</a:t>
+            </a:r>
+          </a:p>
+        </p:txBody>
+      </p:sp>
+      <p:sp>
+        <p:nvSpPr>
+          <p:cNvPr id="55" name="TextBox 54"/>
           <p:cNvSpPr txBox="1"/>
           <p:nvPr/>
         </p:nvSpPr>
@@ -21690,7 +23744,7 @@
       </p:sp>
       <p:sp>
         <p:nvSpPr>
-          <p:cNvPr id="8" name="TextBox 7"/>
+          <p:cNvPr id="56" name="TextBox 55"/>
           <p:cNvSpPr txBox="1"/>
           <p:nvPr/>
         </p:nvSpPr>
@@ -21729,7 +23783,7 @@
       </p:sp>
       <p:sp>
         <p:nvSpPr>
-          <p:cNvPr id="9" name="TextBox 8"/>
+          <p:cNvPr id="57" name="TextBox 56"/>
           <p:cNvSpPr txBox="1"/>
           <p:nvPr/>
         </p:nvSpPr>
@@ -21768,7 +23822,7 @@
       </p:sp>
       <p:sp>
         <p:nvSpPr>
-          <p:cNvPr id="10" name="Rectangle 9"/>
+          <p:cNvPr id="58" name="Rectangle 57"/>
           <p:cNvSpPr/>
           <p:nvPr/>
         </p:nvSpPr>
@@ -22309,7 +24363,7 @@
                 </a:solidFill>
                 <a:latin typeface="JetBrains Mono"/>
               </a:rPr>
-              <a:t>CIERRE</a:t>
+              <a:t>08 · ESTADO ACTUAL</a:t>
             </a:r>
           </a:p>
         </p:txBody>
@@ -22348,7 +24402,7 @@
                 </a:solidFill>
                 <a:latin typeface="Space Grotesk"/>
               </a:rPr>
-              <a:t>En resumen</a:t>
+              <a:t>Próximos pasos</a:t>
             </a:r>
           </a:p>
         </p:txBody>
@@ -22407,7 +24461,7 @@
         <p:spPr>
           <a:xfrm>
             <a:off x="777240" y="2103120"/>
-            <a:ext cx="10241280" cy="3291840"/>
+            <a:ext cx="10241280" cy="3108960"/>
           </a:xfrm>
           <a:prstGeom prst="rect">
             <a:avLst/>
@@ -22422,14 +24476,14 @@
           <a:p>
             <a:pPr>
               <a:lnSpc>
-                <a:spcPct val="145000"/>
+                <a:spcPct val="160000"/>
               </a:lnSpc>
               <a:spcAft>
                 <a:spcPts val="400"/>
               </a:spcAft>
             </a:pPr>
             <a:r>
-              <a:rPr sz="1550" b="1">
+              <a:rPr sz="1650" b="1">
                 <a:solidFill>
                   <a:srgbClr val="C9A45C"/>
                 </a:solidFill>
@@ -22438,35 +24492,26 @@
               <a:t>▪  </a:t>
             </a:r>
             <a:r>
-              <a:rPr sz="1550" b="1">
-                <a:solidFill>
-                  <a:srgbClr val="E7E9ED"/>
-                </a:solidFill>
-                <a:latin typeface="Space Grotesk"/>
-              </a:rPr>
-              <a:t>Todo en un solo lugar.</a:t>
-            </a:r>
-            <a:r>
-              <a:rPr sz="1550">
+              <a:rPr sz="1650">
                 <a:solidFill>
                   <a:srgbClr val="99A0AB"/>
                 </a:solidFill>
                 <a:latin typeface="Space Grotesk"/>
               </a:rPr>
-              <a:t> cartera, indicadores, alertas e informes conectados</a:t>
+              <a:t>Vista consolidada multi-cartera y multi-moneda</a:t>
             </a:r>
           </a:p>
           <a:p>
             <a:pPr>
               <a:lnSpc>
-                <a:spcPct val="145000"/>
+                <a:spcPct val="160000"/>
               </a:lnSpc>
               <a:spcAft>
                 <a:spcPts val="400"/>
               </a:spcAft>
             </a:pPr>
             <a:r>
-              <a:rPr sz="1550" b="1">
+              <a:rPr sz="1650" b="1">
                 <a:solidFill>
                   <a:srgbClr val="C9A45C"/>
                 </a:solidFill>
@@ -22475,35 +24520,26 @@
               <a:t>▪  </a:t>
             </a:r>
             <a:r>
-              <a:rPr sz="1550" b="1">
-                <a:solidFill>
-                  <a:srgbClr val="E7E9ED"/>
-                </a:solidFill>
-                <a:latin typeface="Space Grotesk"/>
-              </a:rPr>
-              <a:t>Resiliencia de datos.</a:t>
-            </a:r>
-            <a:r>
-              <a:rPr sz="1550">
+              <a:rPr sz="1650">
                 <a:solidFill>
                   <a:srgbClr val="99A0AB"/>
                 </a:solidFill>
                 <a:latin typeface="Space Grotesk"/>
               </a:rPr>
-              <a:t> un hub técnico con cascada de proveedores que nunca falla en silencio</a:t>
+              <a:t>Notificaciones push (PWA)</a:t>
             </a:r>
           </a:p>
           <a:p>
             <a:pPr>
               <a:lnSpc>
-                <a:spcPct val="145000"/>
+                <a:spcPct val="160000"/>
               </a:lnSpc>
               <a:spcAft>
                 <a:spcPts val="400"/>
               </a:spcAft>
             </a:pPr>
             <a:r>
-              <a:rPr sz="1550" b="1">
+              <a:rPr sz="1650" b="1">
                 <a:solidFill>
                   <a:srgbClr val="C9A45C"/>
                 </a:solidFill>
@@ -22512,35 +24548,26 @@
               <a:t>▪  </a:t>
             </a:r>
             <a:r>
-              <a:rPr sz="1550" b="1">
-                <a:solidFill>
-                  <a:srgbClr val="E7E9ED"/>
-                </a:solidFill>
-                <a:latin typeface="Space Grotesk"/>
-              </a:rPr>
-              <a:t>IA aplicada de verdad.</a:t>
-            </a:r>
-            <a:r>
-              <a:rPr sz="1550">
+              <a:rPr sz="1650">
                 <a:solidFill>
                   <a:srgbClr val="99A0AB"/>
                 </a:solidFill>
                 <a:latin typeface="Space Grotesk"/>
               </a:rPr>
-              <a:t> extracción real de señales financieras, con proveedores intercambiables</a:t>
+              <a:t>Fuentes adicionales de análisis con IA (noticias, feeds automáticos)</a:t>
             </a:r>
           </a:p>
           <a:p>
             <a:pPr>
               <a:lnSpc>
-                <a:spcPct val="145000"/>
+                <a:spcPct val="160000"/>
               </a:lnSpc>
               <a:spcAft>
                 <a:spcPts val="400"/>
               </a:spcAft>
             </a:pPr>
             <a:r>
-              <a:rPr sz="1550" b="1">
+              <a:rPr sz="1650" b="1">
                 <a:solidFill>
                   <a:srgbClr val="C9A45C"/>
                 </a:solidFill>
@@ -22549,35 +24576,26 @@
               <a:t>▪  </a:t>
             </a:r>
             <a:r>
-              <a:rPr sz="1550" b="1">
-                <a:solidFill>
-                  <a:srgbClr val="E7E9ED"/>
-                </a:solidFill>
-                <a:latin typeface="Space Grotesk"/>
-              </a:rPr>
-              <a:t>Administración robusta.</a:t>
-            </a:r>
-            <a:r>
-              <a:rPr sz="1550">
+              <a:rPr sz="1650">
                 <a:solidFill>
                   <a:srgbClr val="99A0AB"/>
                 </a:solidFill>
                 <a:latin typeface="Space Grotesk"/>
               </a:rPr>
-              <a:t> roles y permisos granulares, control total del hub sin tocar código</a:t>
+              <a:t>Roles y permisos adicionales según necesidades reales de uso</a:t>
             </a:r>
           </a:p>
           <a:p>
             <a:pPr>
               <a:lnSpc>
-                <a:spcPct val="145000"/>
+                <a:spcPct val="160000"/>
               </a:lnSpc>
               <a:spcAft>
                 <a:spcPts val="400"/>
               </a:spcAft>
             </a:pPr>
             <a:r>
-              <a:rPr sz="1550" b="1">
+              <a:rPr sz="1650" b="1">
                 <a:solidFill>
                   <a:srgbClr val="C9A45C"/>
                 </a:solidFill>
@@ -22586,22 +24604,13 @@
               <a:t>▪  </a:t>
             </a:r>
             <a:r>
-              <a:rPr sz="1550" b="1">
-                <a:solidFill>
-                  <a:srgbClr val="E7E9ED"/>
-                </a:solidFill>
-                <a:latin typeface="Space Grotesk"/>
-              </a:rPr>
-              <a:t>Arquitectura sin deuda técnica.</a:t>
-            </a:r>
-            <a:r>
-              <a:rPr sz="1550">
+              <a:rPr sz="1650">
                 <a:solidFill>
                   <a:srgbClr val="99A0AB"/>
                 </a:solidFill>
                 <a:latin typeface="Space Grotesk"/>
               </a:rPr>
-              <a:t> estándares web, stack aburrido y fiable, todo documentado en specs</a:t>
+              <a:t>Generación automática de tipos frontend/backend desde OpenAPI</a:t>
             </a:r>
           </a:p>
         </p:txBody>
@@ -22679,7 +24688,7 @@
                 </a:solidFill>
                 <a:latin typeface="JetBrains Mono"/>
               </a:rPr>
-              <a:t>CIERRE</a:t>
+              <a:t>08 · ESTADO ACTUAL</a:t>
             </a:r>
           </a:p>
         </p:txBody>
@@ -22777,6 +24786,569 @@
 </file>
 
 <file path=ppt/slides/slide31.xml><?xml version="1.0" encoding="utf-8"?>
+<p:sld xmlns:a="http://schemas.openxmlformats.org/drawingml/2006/main" xmlns:r="http://schemas.openxmlformats.org/officeDocument/2006/relationships" xmlns:p="http://schemas.openxmlformats.org/presentationml/2006/main">
+  <p:cSld>
+    <p:spTree>
+      <p:nvGrpSpPr>
+        <p:cNvPr id="1" name=""/>
+        <p:cNvGrpSpPr/>
+        <p:nvPr/>
+      </p:nvGrpSpPr>
+      <p:grpSpPr>
+        <a:xfrm>
+          <a:off x="0" y="0"/>
+          <a:ext cx="0" cy="0"/>
+          <a:chOff x="0" y="0"/>
+          <a:chExt cx="0" cy="0"/>
+        </a:xfrm>
+      </p:grpSpPr>
+      <p:sp>
+        <p:nvSpPr>
+          <p:cNvPr id="2" name="Rectangle 1"/>
+          <p:cNvSpPr/>
+          <p:nvPr/>
+        </p:nvSpPr>
+        <p:spPr>
+          <a:xfrm>
+            <a:off x="0" y="0"/>
+            <a:ext cx="12191695" cy="6858000"/>
+          </a:xfrm>
+          <a:prstGeom prst="rect">
+            <a:avLst/>
+          </a:prstGeom>
+          <a:solidFill>
+            <a:srgbClr val="08090B"/>
+          </a:solidFill>
+          <a:ln>
+            <a:noFill/>
+          </a:ln>
+          <a:effectLst/>
+        </p:spPr>
+        <p:style>
+          <a:lnRef idx="1">
+            <a:schemeClr val="accent1"/>
+          </a:lnRef>
+          <a:fillRef idx="3">
+            <a:schemeClr val="accent1"/>
+          </a:fillRef>
+          <a:effectRef idx="2">
+            <a:schemeClr val="accent1"/>
+          </a:effectRef>
+          <a:fontRef idx="minor">
+            <a:schemeClr val="lt1"/>
+          </a:fontRef>
+        </p:style>
+        <p:txBody>
+          <a:bodyPr rtlCol="0" anchor="ctr"/>
+          <a:lstStyle/>
+          <a:p>
+            <a:pPr algn="ctr"/>
+            <a:endParaRPr/>
+          </a:p>
+        </p:txBody>
+      </p:sp>
+      <p:sp>
+        <p:nvSpPr>
+          <p:cNvPr id="3" name="TextBox 2"/>
+          <p:cNvSpPr txBox="1"/>
+          <p:nvPr/>
+        </p:nvSpPr>
+        <p:spPr>
+          <a:xfrm>
+            <a:off x="685800" y="457200"/>
+            <a:ext cx="10789920" cy="365760"/>
+          </a:xfrm>
+          <a:prstGeom prst="rect">
+            <a:avLst/>
+          </a:prstGeom>
+          <a:noFill/>
+        </p:spPr>
+        <p:txBody>
+          <a:bodyPr wrap="square" lIns="0" tIns="0" rIns="0" bIns="0" anchor="t">
+            <a:spAutoFit/>
+          </a:bodyPr>
+          <a:lstStyle/>
+          <a:p>
+            <a:pPr algn="l">
+              <a:lnSpc>
+                <a:spcPct val="115000"/>
+              </a:lnSpc>
+            </a:pPr>
+            <a:r>
+              <a:rPr sz="1300" b="1" i="0">
+                <a:solidFill>
+                  <a:srgbClr val="C9A45C"/>
+                </a:solidFill>
+                <a:latin typeface="JetBrains Mono"/>
+              </a:rPr>
+              <a:t>CIERRE</a:t>
+            </a:r>
+          </a:p>
+        </p:txBody>
+      </p:sp>
+      <p:sp>
+        <p:nvSpPr>
+          <p:cNvPr id="4" name="TextBox 3"/>
+          <p:cNvSpPr txBox="1"/>
+          <p:nvPr/>
+        </p:nvSpPr>
+        <p:spPr>
+          <a:xfrm>
+            <a:off x="685800" y="786384"/>
+            <a:ext cx="10789920" cy="731520"/>
+          </a:xfrm>
+          <a:prstGeom prst="rect">
+            <a:avLst/>
+          </a:prstGeom>
+          <a:noFill/>
+        </p:spPr>
+        <p:txBody>
+          <a:bodyPr wrap="square" lIns="0" tIns="0" rIns="0" bIns="0" anchor="t">
+            <a:spAutoFit/>
+          </a:bodyPr>
+          <a:lstStyle/>
+          <a:p>
+            <a:pPr algn="l">
+              <a:lnSpc>
+                <a:spcPct val="115000"/>
+              </a:lnSpc>
+            </a:pPr>
+            <a:r>
+              <a:rPr sz="3000" b="1" i="0">
+                <a:solidFill>
+                  <a:srgbClr val="E7E9ED"/>
+                </a:solidFill>
+                <a:latin typeface="Space Grotesk"/>
+              </a:rPr>
+              <a:t>En resumen</a:t>
+            </a:r>
+          </a:p>
+        </p:txBody>
+      </p:sp>
+      <p:sp>
+        <p:nvSpPr>
+          <p:cNvPr id="5" name="Rectangle 4"/>
+          <p:cNvSpPr/>
+          <p:nvPr/>
+        </p:nvSpPr>
+        <p:spPr>
+          <a:xfrm>
+            <a:off x="685800" y="1444752"/>
+            <a:ext cx="502920" cy="38100"/>
+          </a:xfrm>
+          <a:prstGeom prst="rect">
+            <a:avLst/>
+          </a:prstGeom>
+          <a:solidFill>
+            <a:srgbClr val="C9A45C"/>
+          </a:solidFill>
+          <a:ln>
+            <a:noFill/>
+          </a:ln>
+          <a:effectLst/>
+        </p:spPr>
+        <p:style>
+          <a:lnRef idx="1">
+            <a:schemeClr val="accent1"/>
+          </a:lnRef>
+          <a:fillRef idx="3">
+            <a:schemeClr val="accent1"/>
+          </a:fillRef>
+          <a:effectRef idx="2">
+            <a:schemeClr val="accent1"/>
+          </a:effectRef>
+          <a:fontRef idx="minor">
+            <a:schemeClr val="lt1"/>
+          </a:fontRef>
+        </p:style>
+        <p:txBody>
+          <a:bodyPr rtlCol="0" anchor="ctr"/>
+          <a:lstStyle/>
+          <a:p>
+            <a:pPr algn="ctr"/>
+            <a:endParaRPr/>
+          </a:p>
+        </p:txBody>
+      </p:sp>
+      <p:sp>
+        <p:nvSpPr>
+          <p:cNvPr id="6" name="TextBox 5"/>
+          <p:cNvSpPr txBox="1"/>
+          <p:nvPr/>
+        </p:nvSpPr>
+        <p:spPr>
+          <a:xfrm>
+            <a:off x="777240" y="2103120"/>
+            <a:ext cx="10241280" cy="3291840"/>
+          </a:xfrm>
+          <a:prstGeom prst="rect">
+            <a:avLst/>
+          </a:prstGeom>
+          <a:noFill/>
+        </p:spPr>
+        <p:txBody>
+          <a:bodyPr wrap="square" lIns="0" tIns="0" rIns="0" bIns="0">
+            <a:spAutoFit/>
+          </a:bodyPr>
+          <a:lstStyle/>
+          <a:p>
+            <a:pPr>
+              <a:lnSpc>
+                <a:spcPct val="145000"/>
+              </a:lnSpc>
+              <a:spcAft>
+                <a:spcPts val="400"/>
+              </a:spcAft>
+            </a:pPr>
+            <a:r>
+              <a:rPr sz="1550" b="1">
+                <a:solidFill>
+                  <a:srgbClr val="C9A45C"/>
+                </a:solidFill>
+                <a:latin typeface="Space Grotesk"/>
+              </a:rPr>
+              <a:t>▪  </a:t>
+            </a:r>
+            <a:r>
+              <a:rPr sz="1550" b="1">
+                <a:solidFill>
+                  <a:srgbClr val="E7E9ED"/>
+                </a:solidFill>
+                <a:latin typeface="Space Grotesk"/>
+              </a:rPr>
+              <a:t>Todo en un solo lugar.</a:t>
+            </a:r>
+            <a:r>
+              <a:rPr sz="1550">
+                <a:solidFill>
+                  <a:srgbClr val="99A0AB"/>
+                </a:solidFill>
+                <a:latin typeface="Space Grotesk"/>
+              </a:rPr>
+              <a:t> cartera, indicadores, alertas e informes conectados</a:t>
+            </a:r>
+          </a:p>
+          <a:p>
+            <a:pPr>
+              <a:lnSpc>
+                <a:spcPct val="145000"/>
+              </a:lnSpc>
+              <a:spcAft>
+                <a:spcPts val="400"/>
+              </a:spcAft>
+            </a:pPr>
+            <a:r>
+              <a:rPr sz="1550" b="1">
+                <a:solidFill>
+                  <a:srgbClr val="C9A45C"/>
+                </a:solidFill>
+                <a:latin typeface="Space Grotesk"/>
+              </a:rPr>
+              <a:t>▪  </a:t>
+            </a:r>
+            <a:r>
+              <a:rPr sz="1550" b="1">
+                <a:solidFill>
+                  <a:srgbClr val="E7E9ED"/>
+                </a:solidFill>
+                <a:latin typeface="Space Grotesk"/>
+              </a:rPr>
+              <a:t>Resiliencia de datos.</a:t>
+            </a:r>
+            <a:r>
+              <a:rPr sz="1550">
+                <a:solidFill>
+                  <a:srgbClr val="99A0AB"/>
+                </a:solidFill>
+                <a:latin typeface="Space Grotesk"/>
+              </a:rPr>
+              <a:t> un hub técnico con cascada de proveedores que nunca falla en silencio</a:t>
+            </a:r>
+          </a:p>
+          <a:p>
+            <a:pPr>
+              <a:lnSpc>
+                <a:spcPct val="145000"/>
+              </a:lnSpc>
+              <a:spcAft>
+                <a:spcPts val="400"/>
+              </a:spcAft>
+            </a:pPr>
+            <a:r>
+              <a:rPr sz="1550" b="1">
+                <a:solidFill>
+                  <a:srgbClr val="C9A45C"/>
+                </a:solidFill>
+                <a:latin typeface="Space Grotesk"/>
+              </a:rPr>
+              <a:t>▪  </a:t>
+            </a:r>
+            <a:r>
+              <a:rPr sz="1550" b="1">
+                <a:solidFill>
+                  <a:srgbClr val="E7E9ED"/>
+                </a:solidFill>
+                <a:latin typeface="Space Grotesk"/>
+              </a:rPr>
+              <a:t>IA aplicada de verdad.</a:t>
+            </a:r>
+            <a:r>
+              <a:rPr sz="1550">
+                <a:solidFill>
+                  <a:srgbClr val="99A0AB"/>
+                </a:solidFill>
+                <a:latin typeface="Space Grotesk"/>
+              </a:rPr>
+              <a:t> extracción real de señales financieras, con proveedores intercambiables</a:t>
+            </a:r>
+          </a:p>
+          <a:p>
+            <a:pPr>
+              <a:lnSpc>
+                <a:spcPct val="145000"/>
+              </a:lnSpc>
+              <a:spcAft>
+                <a:spcPts val="400"/>
+              </a:spcAft>
+            </a:pPr>
+            <a:r>
+              <a:rPr sz="1550" b="1">
+                <a:solidFill>
+                  <a:srgbClr val="C9A45C"/>
+                </a:solidFill>
+                <a:latin typeface="Space Grotesk"/>
+              </a:rPr>
+              <a:t>▪  </a:t>
+            </a:r>
+            <a:r>
+              <a:rPr sz="1550" b="1">
+                <a:solidFill>
+                  <a:srgbClr val="E7E9ED"/>
+                </a:solidFill>
+                <a:latin typeface="Space Grotesk"/>
+              </a:rPr>
+              <a:t>Administración robusta.</a:t>
+            </a:r>
+            <a:r>
+              <a:rPr sz="1550">
+                <a:solidFill>
+                  <a:srgbClr val="99A0AB"/>
+                </a:solidFill>
+                <a:latin typeface="Space Grotesk"/>
+              </a:rPr>
+              <a:t> roles y permisos granulares, control total del hub sin tocar código</a:t>
+            </a:r>
+          </a:p>
+          <a:p>
+            <a:pPr>
+              <a:lnSpc>
+                <a:spcPct val="145000"/>
+              </a:lnSpc>
+              <a:spcAft>
+                <a:spcPts val="400"/>
+              </a:spcAft>
+            </a:pPr>
+            <a:r>
+              <a:rPr sz="1550" b="1">
+                <a:solidFill>
+                  <a:srgbClr val="C9A45C"/>
+                </a:solidFill>
+                <a:latin typeface="Space Grotesk"/>
+              </a:rPr>
+              <a:t>▪  </a:t>
+            </a:r>
+            <a:r>
+              <a:rPr sz="1550" b="1">
+                <a:solidFill>
+                  <a:srgbClr val="E7E9ED"/>
+                </a:solidFill>
+                <a:latin typeface="Space Grotesk"/>
+              </a:rPr>
+              <a:t>Arquitectura sin deuda técnica.</a:t>
+            </a:r>
+            <a:r>
+              <a:rPr sz="1550">
+                <a:solidFill>
+                  <a:srgbClr val="99A0AB"/>
+                </a:solidFill>
+                <a:latin typeface="Space Grotesk"/>
+              </a:rPr>
+              <a:t> estándares web, stack aburrido y fiable, todo documentado en specs</a:t>
+            </a:r>
+          </a:p>
+        </p:txBody>
+      </p:sp>
+      <p:sp>
+        <p:nvSpPr>
+          <p:cNvPr id="7" name="TextBox 6"/>
+          <p:cNvSpPr txBox="1"/>
+          <p:nvPr/>
+        </p:nvSpPr>
+        <p:spPr>
+          <a:xfrm>
+            <a:off x="685800" y="6473952"/>
+            <a:ext cx="5486400" cy="274320"/>
+          </a:xfrm>
+          <a:prstGeom prst="rect">
+            <a:avLst/>
+          </a:prstGeom>
+          <a:noFill/>
+        </p:spPr>
+        <p:txBody>
+          <a:bodyPr wrap="square" lIns="0" tIns="0" rIns="0" bIns="0" anchor="t">
+            <a:spAutoFit/>
+          </a:bodyPr>
+          <a:lstStyle/>
+          <a:p>
+            <a:pPr algn="l">
+              <a:lnSpc>
+                <a:spcPct val="115000"/>
+              </a:lnSpc>
+            </a:pPr>
+            <a:r>
+              <a:rPr sz="850" b="0" i="0">
+                <a:solidFill>
+                  <a:srgbClr val="5C6472"/>
+                </a:solidFill>
+                <a:latin typeface="JetBrains Mono"/>
+              </a:rPr>
+              <a:t>TFM BIGSCHOOL · GESTIÓN DE CARTERA FINANCIERA CON IA</a:t>
+            </a:r>
+          </a:p>
+        </p:txBody>
+      </p:sp>
+      <p:sp>
+        <p:nvSpPr>
+          <p:cNvPr id="8" name="TextBox 7"/>
+          <p:cNvSpPr txBox="1"/>
+          <p:nvPr/>
+        </p:nvSpPr>
+        <p:spPr>
+          <a:xfrm>
+            <a:off x="5943600" y="6473952"/>
+            <a:ext cx="4389120" cy="274320"/>
+          </a:xfrm>
+          <a:prstGeom prst="rect">
+            <a:avLst/>
+          </a:prstGeom>
+          <a:noFill/>
+        </p:spPr>
+        <p:txBody>
+          <a:bodyPr wrap="square" lIns="0" tIns="0" rIns="0" bIns="0" anchor="t">
+            <a:spAutoFit/>
+          </a:bodyPr>
+          <a:lstStyle/>
+          <a:p>
+            <a:pPr algn="r">
+              <a:lnSpc>
+                <a:spcPct val="115000"/>
+              </a:lnSpc>
+            </a:pPr>
+            <a:r>
+              <a:rPr sz="850" b="0" i="0">
+                <a:solidFill>
+                  <a:srgbClr val="5C6472"/>
+                </a:solidFill>
+                <a:latin typeface="JetBrains Mono"/>
+              </a:rPr>
+              <a:t>CIERRE</a:t>
+            </a:r>
+          </a:p>
+        </p:txBody>
+      </p:sp>
+      <p:sp>
+        <p:nvSpPr>
+          <p:cNvPr id="9" name="TextBox 8"/>
+          <p:cNvSpPr txBox="1"/>
+          <p:nvPr/>
+        </p:nvSpPr>
+        <p:spPr>
+          <a:xfrm>
+            <a:off x="11475720" y="6473952"/>
+            <a:ext cx="548640" cy="274320"/>
+          </a:xfrm>
+          <a:prstGeom prst="rect">
+            <a:avLst/>
+          </a:prstGeom>
+          <a:noFill/>
+        </p:spPr>
+        <p:txBody>
+          <a:bodyPr wrap="square" lIns="0" tIns="0" rIns="0" bIns="0" anchor="t">
+            <a:spAutoFit/>
+          </a:bodyPr>
+          <a:lstStyle/>
+          <a:p>
+            <a:pPr algn="r">
+              <a:lnSpc>
+                <a:spcPct val="115000"/>
+              </a:lnSpc>
+            </a:pPr>
+            <a:r>
+              <a:rPr sz="850" b="0" i="0">
+                <a:solidFill>
+                  <a:srgbClr val="C9A45C"/>
+                </a:solidFill>
+                <a:latin typeface="JetBrains Mono"/>
+              </a:rPr>
+              <a:t>30</a:t>
+            </a:r>
+          </a:p>
+        </p:txBody>
+      </p:sp>
+      <p:sp>
+        <p:nvSpPr>
+          <p:cNvPr id="10" name="Rectangle 9"/>
+          <p:cNvSpPr/>
+          <p:nvPr/>
+        </p:nvSpPr>
+        <p:spPr>
+          <a:xfrm>
+            <a:off x="685800" y="6400800"/>
+            <a:ext cx="10817352" cy="9525"/>
+          </a:xfrm>
+          <a:prstGeom prst="rect">
+            <a:avLst/>
+          </a:prstGeom>
+          <a:solidFill>
+            <a:srgbClr val="1D222B"/>
+          </a:solidFill>
+          <a:ln>
+            <a:noFill/>
+          </a:ln>
+          <a:effectLst/>
+        </p:spPr>
+        <p:style>
+          <a:lnRef idx="1">
+            <a:schemeClr val="accent1"/>
+          </a:lnRef>
+          <a:fillRef idx="3">
+            <a:schemeClr val="accent1"/>
+          </a:fillRef>
+          <a:effectRef idx="2">
+            <a:schemeClr val="accent1"/>
+          </a:effectRef>
+          <a:fontRef idx="minor">
+            <a:schemeClr val="lt1"/>
+          </a:fontRef>
+        </p:style>
+        <p:txBody>
+          <a:bodyPr rtlCol="0" anchor="ctr"/>
+          <a:lstStyle/>
+          <a:p>
+            <a:pPr algn="ctr"/>
+            <a:endParaRPr/>
+          </a:p>
+        </p:txBody>
+      </p:sp>
+    </p:spTree>
+  </p:cSld>
+  <p:clrMapOvr>
+    <a:masterClrMapping/>
+  </p:clrMapOvr>
+</p:sld>
+</file>
+
+<file path=ppt/slides/slide32.xml><?xml version="1.0" encoding="utf-8"?>
 <p:sld xmlns:a="http://schemas.openxmlformats.org/drawingml/2006/main" xmlns:r="http://schemas.openxmlformats.org/officeDocument/2006/relationships" xmlns:p="http://schemas.openxmlformats.org/presentationml/2006/main">
   <p:cSld>
     <p:spTree>

</xml_diff>